<commit_message>
security(stage-1): trust proxy, rate limits /register+/refresh, fix CORS, explicit JWT algorithm+jti+iss+aud, hpp middleware, nginx SSL hardening, fix port mismatch
</commit_message>
<xml_diff>
--- a/docs/docx/MedCampus-UTS-Presentasi.pptx
+++ b/docs/docx/MedCampus-UTS-Presentasi.pptx
@@ -5,35 +5,35 @@
     <p:sldMasterId id="2147483648" r:id="rId1"/>
   </p:sldMasterIdLst>
   <p:sldIdLst>
-    <p:sldId id="256" r:id="rId7"/>
-    <p:sldId id="257" r:id="rId8"/>
-    <p:sldId id="258" r:id="rId9"/>
-    <p:sldId id="259" r:id="rId10"/>
-    <p:sldId id="260" r:id="rId11"/>
-    <p:sldId id="261" r:id="rId12"/>
-    <p:sldId id="262" r:id="rId13"/>
-    <p:sldId id="263" r:id="rId14"/>
-    <p:sldId id="264" r:id="rId15"/>
-    <p:sldId id="265" r:id="rId16"/>
-    <p:sldId id="266" r:id="rId17"/>
-    <p:sldId id="267" r:id="rId18"/>
-    <p:sldId id="268" r:id="rId19"/>
-    <p:sldId id="269" r:id="rId20"/>
-    <p:sldId id="270" r:id="rId21"/>
-    <p:sldId id="271" r:id="rId22"/>
-    <p:sldId id="272" r:id="rId23"/>
-    <p:sldId id="273" r:id="rId24"/>
-    <p:sldId id="274" r:id="rId25"/>
-    <p:sldId id="275" r:id="rId26"/>
-    <p:sldId id="276" r:id="rId27"/>
-    <p:sldId id="277" r:id="rId28"/>
-    <p:sldId id="278" r:id="rId29"/>
-    <p:sldId id="279" r:id="rId30"/>
-    <p:sldId id="280" r:id="rId31"/>
-    <p:sldId id="281" r:id="rId32"/>
-    <p:sldId id="282" r:id="rId33"/>
+    <p:sldId id="256" r:id="rId2"/>
+    <p:sldId id="257" r:id="rId3"/>
+    <p:sldId id="258" r:id="rId4"/>
+    <p:sldId id="259" r:id="rId5"/>
+    <p:sldId id="260" r:id="rId6"/>
+    <p:sldId id="261" r:id="rId7"/>
+    <p:sldId id="262" r:id="rId8"/>
+    <p:sldId id="263" r:id="rId9"/>
+    <p:sldId id="264" r:id="rId10"/>
+    <p:sldId id="265" r:id="rId11"/>
+    <p:sldId id="266" r:id="rId12"/>
+    <p:sldId id="267" r:id="rId13"/>
+    <p:sldId id="268" r:id="rId14"/>
+    <p:sldId id="269" r:id="rId15"/>
+    <p:sldId id="270" r:id="rId16"/>
+    <p:sldId id="271" r:id="rId17"/>
+    <p:sldId id="272" r:id="rId18"/>
+    <p:sldId id="273" r:id="rId19"/>
+    <p:sldId id="274" r:id="rId20"/>
+    <p:sldId id="275" r:id="rId21"/>
+    <p:sldId id="276" r:id="rId22"/>
+    <p:sldId id="277" r:id="rId23"/>
+    <p:sldId id="278" r:id="rId24"/>
+    <p:sldId id="279" r:id="rId25"/>
+    <p:sldId id="280" r:id="rId26"/>
+    <p:sldId id="281" r:id="rId27"/>
+    <p:sldId id="282" r:id="rId28"/>
   </p:sldIdLst>
-  <p:sldSz cx="12188952" cy="6858000" type="screen4x3"/>
+  <p:sldSz cx="12188825" cy="6858000"/>
   <p:notesSz cx="6858000" cy="9144000"/>
   <p:defaultTextStyle>
     <a:defPPr>
@@ -130,6 +130,22 @@
       </a:defRPr>
     </a:lvl9pPr>
   </p:defaultTextStyle>
+  <p:extLst>
+    <p:ext uri="{EFAFB233-063F-42B5-8137-9DF3F51BA10A}">
+      <p15:sldGuideLst xmlns:p15="http://schemas.microsoft.com/office/powerpoint/2012/main">
+        <p15:guide id="1" orient="horz" pos="2160">
+          <p15:clr>
+            <a:srgbClr val="A4A3A4"/>
+          </p15:clr>
+        </p15:guide>
+        <p15:guide id="2" pos="2880">
+          <p15:clr>
+            <a:srgbClr val="A4A3A4"/>
+          </p15:clr>
+        </p15:guide>
+      </p15:sldGuideLst>
+    </p:ext>
+  </p:extLst>
 </p:presentation>
 </file>
 
@@ -171,10 +187,9 @@
           <a:lstStyle/>
           <a:p>
             <a:r>
-              <a:rPr lang="en-US" smtClean="0"/>
+              <a:rPr lang="en-US"/>
               <a:t>Click to edit Master title style</a:t>
             </a:r>
-            <a:endParaRPr lang="en-US"/>
           </a:p>
         </p:txBody>
       </p:sp>
@@ -290,10 +305,9 @@
           </a:lstStyle>
           <a:p>
             <a:r>
-              <a:rPr lang="en-US" smtClean="0"/>
+              <a:rPr lang="en-US"/>
               <a:t>Click to edit Master subtitle style</a:t>
             </a:r>
-            <a:endParaRPr lang="en-US"/>
           </a:p>
         </p:txBody>
       </p:sp>
@@ -314,7 +328,7 @@
           <a:p>
             <a:fld id="{5BCAD085-E8A6-8845-BD4E-CB4CCA059FC4}" type="datetimeFigureOut">
               <a:rPr lang="en-US" smtClean="0"/>
-              <a:t>1/27/13</a:t>
+              <a:t>7/30/2026</a:t>
             </a:fld>
             <a:endParaRPr lang="en-US"/>
           </a:p>
@@ -408,10 +422,9 @@
           <a:lstStyle/>
           <a:p>
             <a:r>
-              <a:rPr lang="en-US" smtClean="0"/>
+              <a:rPr lang="en-US"/>
               <a:t>Click to edit Master title style</a:t>
             </a:r>
-            <a:endParaRPr lang="en-US"/>
           </a:p>
         </p:txBody>
       </p:sp>
@@ -432,38 +445,37 @@
           <a:p>
             <a:pPr lvl="0"/>
             <a:r>
-              <a:rPr lang="en-US" smtClean="0"/>
+              <a:rPr lang="en-US"/>
               <a:t>Click to edit Master text styles</a:t>
             </a:r>
           </a:p>
           <a:p>
             <a:pPr lvl="1"/>
             <a:r>
-              <a:rPr lang="en-US" smtClean="0"/>
+              <a:rPr lang="en-US"/>
               <a:t>Second level</a:t>
             </a:r>
           </a:p>
           <a:p>
             <a:pPr lvl="2"/>
             <a:r>
-              <a:rPr lang="en-US" smtClean="0"/>
+              <a:rPr lang="en-US"/>
               <a:t>Third level</a:t>
             </a:r>
           </a:p>
           <a:p>
             <a:pPr lvl="3"/>
             <a:r>
-              <a:rPr lang="en-US" smtClean="0"/>
+              <a:rPr lang="en-US"/>
               <a:t>Fourth level</a:t>
             </a:r>
           </a:p>
           <a:p>
             <a:pPr lvl="4"/>
             <a:r>
-              <a:rPr lang="en-US" smtClean="0"/>
+              <a:rPr lang="en-US"/>
               <a:t>Fifth level</a:t>
             </a:r>
-            <a:endParaRPr lang="en-US"/>
           </a:p>
         </p:txBody>
       </p:sp>
@@ -484,7 +496,7 @@
           <a:p>
             <a:fld id="{5BCAD085-E8A6-8845-BD4E-CB4CCA059FC4}" type="datetimeFigureOut">
               <a:rPr lang="en-US" smtClean="0"/>
-              <a:t>1/27/13</a:t>
+              <a:t>7/30/2026</a:t>
             </a:fld>
             <a:endParaRPr lang="en-US"/>
           </a:p>
@@ -583,10 +595,9 @@
           <a:lstStyle/>
           <a:p>
             <a:r>
-              <a:rPr lang="en-US" smtClean="0"/>
+              <a:rPr lang="en-US"/>
               <a:t>Click to edit Master title style</a:t>
             </a:r>
-            <a:endParaRPr lang="en-US"/>
           </a:p>
         </p:txBody>
       </p:sp>
@@ -612,38 +623,37 @@
           <a:p>
             <a:pPr lvl="0"/>
             <a:r>
-              <a:rPr lang="en-US" smtClean="0"/>
+              <a:rPr lang="en-US"/>
               <a:t>Click to edit Master text styles</a:t>
             </a:r>
           </a:p>
           <a:p>
             <a:pPr lvl="1"/>
             <a:r>
-              <a:rPr lang="en-US" smtClean="0"/>
+              <a:rPr lang="en-US"/>
               <a:t>Second level</a:t>
             </a:r>
           </a:p>
           <a:p>
             <a:pPr lvl="2"/>
             <a:r>
-              <a:rPr lang="en-US" smtClean="0"/>
+              <a:rPr lang="en-US"/>
               <a:t>Third level</a:t>
             </a:r>
           </a:p>
           <a:p>
             <a:pPr lvl="3"/>
             <a:r>
-              <a:rPr lang="en-US" smtClean="0"/>
+              <a:rPr lang="en-US"/>
               <a:t>Fourth level</a:t>
             </a:r>
           </a:p>
           <a:p>
             <a:pPr lvl="4"/>
             <a:r>
-              <a:rPr lang="en-US" smtClean="0"/>
+              <a:rPr lang="en-US"/>
               <a:t>Fifth level</a:t>
             </a:r>
-            <a:endParaRPr lang="en-US"/>
           </a:p>
         </p:txBody>
       </p:sp>
@@ -664,7 +674,7 @@
           <a:p>
             <a:fld id="{5BCAD085-E8A6-8845-BD4E-CB4CCA059FC4}" type="datetimeFigureOut">
               <a:rPr lang="en-US" smtClean="0"/>
-              <a:t>1/27/13</a:t>
+              <a:t>7/30/2026</a:t>
             </a:fld>
             <a:endParaRPr lang="en-US"/>
           </a:p>
@@ -758,10 +768,9 @@
           <a:lstStyle/>
           <a:p>
             <a:r>
-              <a:rPr lang="en-US" smtClean="0"/>
+              <a:rPr lang="en-US"/>
               <a:t>Click to edit Master title style</a:t>
             </a:r>
-            <a:endParaRPr lang="en-US"/>
           </a:p>
         </p:txBody>
       </p:sp>
@@ -782,38 +791,37 @@
           <a:p>
             <a:pPr lvl="0"/>
             <a:r>
-              <a:rPr lang="en-US" smtClean="0"/>
+              <a:rPr lang="en-US"/>
               <a:t>Click to edit Master text styles</a:t>
             </a:r>
           </a:p>
           <a:p>
             <a:pPr lvl="1"/>
             <a:r>
-              <a:rPr lang="en-US" smtClean="0"/>
+              <a:rPr lang="en-US"/>
               <a:t>Second level</a:t>
             </a:r>
           </a:p>
           <a:p>
             <a:pPr lvl="2"/>
             <a:r>
-              <a:rPr lang="en-US" smtClean="0"/>
+              <a:rPr lang="en-US"/>
               <a:t>Third level</a:t>
             </a:r>
           </a:p>
           <a:p>
             <a:pPr lvl="3"/>
             <a:r>
-              <a:rPr lang="en-US" smtClean="0"/>
+              <a:rPr lang="en-US"/>
               <a:t>Fourth level</a:t>
             </a:r>
           </a:p>
           <a:p>
             <a:pPr lvl="4"/>
             <a:r>
-              <a:rPr lang="en-US" smtClean="0"/>
+              <a:rPr lang="en-US"/>
               <a:t>Fifth level</a:t>
             </a:r>
-            <a:endParaRPr lang="en-US"/>
           </a:p>
         </p:txBody>
       </p:sp>
@@ -834,7 +842,7 @@
           <a:p>
             <a:fld id="{5BCAD085-E8A6-8845-BD4E-CB4CCA059FC4}" type="datetimeFigureOut">
               <a:rPr lang="en-US" smtClean="0"/>
-              <a:t>1/27/13</a:t>
+              <a:t>7/30/2026</a:t>
             </a:fld>
             <a:endParaRPr lang="en-US"/>
           </a:p>
@@ -937,10 +945,9 @@
           </a:lstStyle>
           <a:p>
             <a:r>
-              <a:rPr lang="en-US" smtClean="0"/>
+              <a:rPr lang="en-US"/>
               <a:t>Click to edit Master title style</a:t>
             </a:r>
-            <a:endParaRPr lang="en-US"/>
           </a:p>
         </p:txBody>
       </p:sp>
@@ -1057,7 +1064,7 @@
           <a:p>
             <a:pPr lvl="0"/>
             <a:r>
-              <a:rPr lang="en-US" smtClean="0"/>
+              <a:rPr lang="en-US"/>
               <a:t>Click to edit Master text styles</a:t>
             </a:r>
           </a:p>
@@ -1080,7 +1087,7 @@
           <a:p>
             <a:fld id="{5BCAD085-E8A6-8845-BD4E-CB4CCA059FC4}" type="datetimeFigureOut">
               <a:rPr lang="en-US" smtClean="0"/>
-              <a:t>1/27/13</a:t>
+              <a:t>7/30/2026</a:t>
             </a:fld>
             <a:endParaRPr lang="en-US"/>
           </a:p>
@@ -1174,10 +1181,9 @@
           <a:lstStyle/>
           <a:p>
             <a:r>
-              <a:rPr lang="en-US" smtClean="0"/>
+              <a:rPr lang="en-US"/>
               <a:t>Click to edit Master title style</a:t>
             </a:r>
-            <a:endParaRPr lang="en-US"/>
           </a:p>
         </p:txBody>
       </p:sp>
@@ -1231,38 +1237,37 @@
           <a:p>
             <a:pPr lvl="0"/>
             <a:r>
-              <a:rPr lang="en-US" smtClean="0"/>
+              <a:rPr lang="en-US"/>
               <a:t>Click to edit Master text styles</a:t>
             </a:r>
           </a:p>
           <a:p>
             <a:pPr lvl="1"/>
             <a:r>
-              <a:rPr lang="en-US" smtClean="0"/>
+              <a:rPr lang="en-US"/>
               <a:t>Second level</a:t>
             </a:r>
           </a:p>
           <a:p>
             <a:pPr lvl="2"/>
             <a:r>
-              <a:rPr lang="en-US" smtClean="0"/>
+              <a:rPr lang="en-US"/>
               <a:t>Third level</a:t>
             </a:r>
           </a:p>
           <a:p>
             <a:pPr lvl="3"/>
             <a:r>
-              <a:rPr lang="en-US" smtClean="0"/>
+              <a:rPr lang="en-US"/>
               <a:t>Fourth level</a:t>
             </a:r>
           </a:p>
           <a:p>
             <a:pPr lvl="4"/>
             <a:r>
-              <a:rPr lang="en-US" smtClean="0"/>
+              <a:rPr lang="en-US"/>
               <a:t>Fifth level</a:t>
             </a:r>
-            <a:endParaRPr lang="en-US"/>
           </a:p>
         </p:txBody>
       </p:sp>
@@ -1316,38 +1321,37 @@
           <a:p>
             <a:pPr lvl="0"/>
             <a:r>
-              <a:rPr lang="en-US" smtClean="0"/>
+              <a:rPr lang="en-US"/>
               <a:t>Click to edit Master text styles</a:t>
             </a:r>
           </a:p>
           <a:p>
             <a:pPr lvl="1"/>
             <a:r>
-              <a:rPr lang="en-US" smtClean="0"/>
+              <a:rPr lang="en-US"/>
               <a:t>Second level</a:t>
             </a:r>
           </a:p>
           <a:p>
             <a:pPr lvl="2"/>
             <a:r>
-              <a:rPr lang="en-US" smtClean="0"/>
+              <a:rPr lang="en-US"/>
               <a:t>Third level</a:t>
             </a:r>
           </a:p>
           <a:p>
             <a:pPr lvl="3"/>
             <a:r>
-              <a:rPr lang="en-US" smtClean="0"/>
+              <a:rPr lang="en-US"/>
               <a:t>Fourth level</a:t>
             </a:r>
           </a:p>
           <a:p>
             <a:pPr lvl="4"/>
             <a:r>
-              <a:rPr lang="en-US" smtClean="0"/>
+              <a:rPr lang="en-US"/>
               <a:t>Fifth level</a:t>
             </a:r>
-            <a:endParaRPr lang="en-US"/>
           </a:p>
         </p:txBody>
       </p:sp>
@@ -1368,7 +1372,7 @@
           <a:p>
             <a:fld id="{5BCAD085-E8A6-8845-BD4E-CB4CCA059FC4}" type="datetimeFigureOut">
               <a:rPr lang="en-US" smtClean="0"/>
-              <a:t>1/27/13</a:t>
+              <a:t>7/30/2026</a:t>
             </a:fld>
             <a:endParaRPr lang="en-US"/>
           </a:p>
@@ -1466,10 +1470,9 @@
           </a:lstStyle>
           <a:p>
             <a:r>
-              <a:rPr lang="en-US" smtClean="0"/>
+              <a:rPr lang="en-US"/>
               <a:t>Click to edit Master title style</a:t>
             </a:r>
-            <a:endParaRPr lang="en-US"/>
           </a:p>
         </p:txBody>
       </p:sp>
@@ -1532,7 +1535,7 @@
           <a:p>
             <a:pPr lvl="0"/>
             <a:r>
-              <a:rPr lang="en-US" smtClean="0"/>
+              <a:rPr lang="en-US"/>
               <a:t>Click to edit Master text styles</a:t>
             </a:r>
           </a:p>
@@ -1588,38 +1591,37 @@
           <a:p>
             <a:pPr lvl="0"/>
             <a:r>
-              <a:rPr lang="en-US" smtClean="0"/>
+              <a:rPr lang="en-US"/>
               <a:t>Click to edit Master text styles</a:t>
             </a:r>
           </a:p>
           <a:p>
             <a:pPr lvl="1"/>
             <a:r>
-              <a:rPr lang="en-US" smtClean="0"/>
+              <a:rPr lang="en-US"/>
               <a:t>Second level</a:t>
             </a:r>
           </a:p>
           <a:p>
             <a:pPr lvl="2"/>
             <a:r>
-              <a:rPr lang="en-US" smtClean="0"/>
+              <a:rPr lang="en-US"/>
               <a:t>Third level</a:t>
             </a:r>
           </a:p>
           <a:p>
             <a:pPr lvl="3"/>
             <a:r>
-              <a:rPr lang="en-US" smtClean="0"/>
+              <a:rPr lang="en-US"/>
               <a:t>Fourth level</a:t>
             </a:r>
           </a:p>
           <a:p>
             <a:pPr lvl="4"/>
             <a:r>
-              <a:rPr lang="en-US" smtClean="0"/>
+              <a:rPr lang="en-US"/>
               <a:t>Fifth level</a:t>
             </a:r>
-            <a:endParaRPr lang="en-US"/>
           </a:p>
         </p:txBody>
       </p:sp>
@@ -1682,7 +1684,7 @@
           <a:p>
             <a:pPr lvl="0"/>
             <a:r>
-              <a:rPr lang="en-US" smtClean="0"/>
+              <a:rPr lang="en-US"/>
               <a:t>Click to edit Master text styles</a:t>
             </a:r>
           </a:p>
@@ -1738,38 +1740,37 @@
           <a:p>
             <a:pPr lvl="0"/>
             <a:r>
-              <a:rPr lang="en-US" smtClean="0"/>
+              <a:rPr lang="en-US"/>
               <a:t>Click to edit Master text styles</a:t>
             </a:r>
           </a:p>
           <a:p>
             <a:pPr lvl="1"/>
             <a:r>
-              <a:rPr lang="en-US" smtClean="0"/>
+              <a:rPr lang="en-US"/>
               <a:t>Second level</a:t>
             </a:r>
           </a:p>
           <a:p>
             <a:pPr lvl="2"/>
             <a:r>
-              <a:rPr lang="en-US" smtClean="0"/>
+              <a:rPr lang="en-US"/>
               <a:t>Third level</a:t>
             </a:r>
           </a:p>
           <a:p>
             <a:pPr lvl="3"/>
             <a:r>
-              <a:rPr lang="en-US" smtClean="0"/>
+              <a:rPr lang="en-US"/>
               <a:t>Fourth level</a:t>
             </a:r>
           </a:p>
           <a:p>
             <a:pPr lvl="4"/>
             <a:r>
-              <a:rPr lang="en-US" smtClean="0"/>
+              <a:rPr lang="en-US"/>
               <a:t>Fifth level</a:t>
             </a:r>
-            <a:endParaRPr lang="en-US"/>
           </a:p>
         </p:txBody>
       </p:sp>
@@ -1790,7 +1791,7 @@
           <a:p>
             <a:fld id="{5BCAD085-E8A6-8845-BD4E-CB4CCA059FC4}" type="datetimeFigureOut">
               <a:rPr lang="en-US" smtClean="0"/>
-              <a:t>1/27/13</a:t>
+              <a:t>7/30/2026</a:t>
             </a:fld>
             <a:endParaRPr lang="en-US"/>
           </a:p>
@@ -1884,10 +1885,9 @@
           <a:lstStyle/>
           <a:p>
             <a:r>
-              <a:rPr lang="en-US" smtClean="0"/>
+              <a:rPr lang="en-US"/>
               <a:t>Click to edit Master title style</a:t>
             </a:r>
-            <a:endParaRPr lang="en-US"/>
           </a:p>
         </p:txBody>
       </p:sp>
@@ -1908,7 +1908,7 @@
           <a:p>
             <a:fld id="{5BCAD085-E8A6-8845-BD4E-CB4CCA059FC4}" type="datetimeFigureOut">
               <a:rPr lang="en-US" smtClean="0"/>
-              <a:t>1/27/13</a:t>
+              <a:t>7/30/2026</a:t>
             </a:fld>
             <a:endParaRPr lang="en-US"/>
           </a:p>
@@ -2003,7 +2003,7 @@
           <a:p>
             <a:fld id="{5BCAD085-E8A6-8845-BD4E-CB4CCA059FC4}" type="datetimeFigureOut">
               <a:rPr lang="en-US" smtClean="0"/>
-              <a:t>1/27/13</a:t>
+              <a:t>7/30/2026</a:t>
             </a:fld>
             <a:endParaRPr lang="en-US"/>
           </a:p>
@@ -2106,10 +2106,9 @@
           </a:lstStyle>
           <a:p>
             <a:r>
-              <a:rPr lang="en-US" smtClean="0"/>
+              <a:rPr lang="en-US"/>
               <a:t>Click to edit Master title style</a:t>
             </a:r>
-            <a:endParaRPr lang="en-US"/>
           </a:p>
         </p:txBody>
       </p:sp>
@@ -2163,38 +2162,37 @@
           <a:p>
             <a:pPr lvl="0"/>
             <a:r>
-              <a:rPr lang="en-US" smtClean="0"/>
+              <a:rPr lang="en-US"/>
               <a:t>Click to edit Master text styles</a:t>
             </a:r>
           </a:p>
           <a:p>
             <a:pPr lvl="1"/>
             <a:r>
-              <a:rPr lang="en-US" smtClean="0"/>
+              <a:rPr lang="en-US"/>
               <a:t>Second level</a:t>
             </a:r>
           </a:p>
           <a:p>
             <a:pPr lvl="2"/>
             <a:r>
-              <a:rPr lang="en-US" smtClean="0"/>
+              <a:rPr lang="en-US"/>
               <a:t>Third level</a:t>
             </a:r>
           </a:p>
           <a:p>
             <a:pPr lvl="3"/>
             <a:r>
-              <a:rPr lang="en-US" smtClean="0"/>
+              <a:rPr lang="en-US"/>
               <a:t>Fourth level</a:t>
             </a:r>
           </a:p>
           <a:p>
             <a:pPr lvl="4"/>
             <a:r>
-              <a:rPr lang="en-US" smtClean="0"/>
+              <a:rPr lang="en-US"/>
               <a:t>Fifth level</a:t>
             </a:r>
-            <a:endParaRPr lang="en-US"/>
           </a:p>
         </p:txBody>
       </p:sp>
@@ -2257,7 +2255,7 @@
           <a:p>
             <a:pPr lvl="0"/>
             <a:r>
-              <a:rPr lang="en-US" smtClean="0"/>
+              <a:rPr lang="en-US"/>
               <a:t>Click to edit Master text styles</a:t>
             </a:r>
           </a:p>
@@ -2280,7 +2278,7 @@
           <a:p>
             <a:fld id="{5BCAD085-E8A6-8845-BD4E-CB4CCA059FC4}" type="datetimeFigureOut">
               <a:rPr lang="en-US" smtClean="0"/>
-              <a:t>1/27/13</a:t>
+              <a:t>7/30/2026</a:t>
             </a:fld>
             <a:endParaRPr lang="en-US"/>
           </a:p>
@@ -2383,10 +2381,9 @@
           </a:lstStyle>
           <a:p>
             <a:r>
-              <a:rPr lang="en-US" smtClean="0"/>
+              <a:rPr lang="en-US"/>
               <a:t>Click to edit Master title style</a:t>
             </a:r>
-            <a:endParaRPr lang="en-US"/>
           </a:p>
         </p:txBody>
       </p:sp>
@@ -2510,7 +2507,7 @@
           <a:p>
             <a:pPr lvl="0"/>
             <a:r>
-              <a:rPr lang="en-US" smtClean="0"/>
+              <a:rPr lang="en-US"/>
               <a:t>Click to edit Master text styles</a:t>
             </a:r>
           </a:p>
@@ -2533,7 +2530,7 @@
           <a:p>
             <a:fld id="{5BCAD085-E8A6-8845-BD4E-CB4CCA059FC4}" type="datetimeFigureOut">
               <a:rPr lang="en-US" smtClean="0"/>
-              <a:t>1/27/13</a:t>
+              <a:t>7/30/2026</a:t>
             </a:fld>
             <a:endParaRPr lang="en-US"/>
           </a:p>
@@ -2642,10 +2639,9 @@
           <a:lstStyle/>
           <a:p>
             <a:r>
-              <a:rPr lang="en-US" smtClean="0"/>
+              <a:rPr lang="en-US"/>
               <a:t>Click to edit Master title style</a:t>
             </a:r>
-            <a:endParaRPr lang="en-US"/>
           </a:p>
         </p:txBody>
       </p:sp>
@@ -2676,38 +2672,37 @@
           <a:p>
             <a:pPr lvl="0"/>
             <a:r>
-              <a:rPr lang="en-US" smtClean="0"/>
+              <a:rPr lang="en-US"/>
               <a:t>Click to edit Master text styles</a:t>
             </a:r>
           </a:p>
           <a:p>
             <a:pPr lvl="1"/>
             <a:r>
-              <a:rPr lang="en-US" smtClean="0"/>
+              <a:rPr lang="en-US"/>
               <a:t>Second level</a:t>
             </a:r>
           </a:p>
           <a:p>
             <a:pPr lvl="2"/>
             <a:r>
-              <a:rPr lang="en-US" smtClean="0"/>
+              <a:rPr lang="en-US"/>
               <a:t>Third level</a:t>
             </a:r>
           </a:p>
           <a:p>
             <a:pPr lvl="3"/>
             <a:r>
-              <a:rPr lang="en-US" smtClean="0"/>
+              <a:rPr lang="en-US"/>
               <a:t>Fourth level</a:t>
             </a:r>
           </a:p>
           <a:p>
             <a:pPr lvl="4"/>
             <a:r>
-              <a:rPr lang="en-US" smtClean="0"/>
+              <a:rPr lang="en-US"/>
               <a:t>Fifth level</a:t>
             </a:r>
-            <a:endParaRPr lang="en-US"/>
           </a:p>
         </p:txBody>
       </p:sp>
@@ -2746,7 +2741,7 @@
           <a:p>
             <a:fld id="{5BCAD085-E8A6-8845-BD4E-CB4CCA059FC4}" type="datetimeFigureOut">
               <a:rPr lang="en-US" smtClean="0"/>
-              <a:t>1/27/13</a:t>
+              <a:t>7/30/2026</a:t>
             </a:fld>
             <a:endParaRPr lang="en-US"/>
           </a:p>
@@ -3105,7 +3100,7 @@
 </file>
 
 <file path=ppt/slides/slide1.xml><?xml version="1.0" encoding="utf-8"?>
-<p:sld xmlns:a="http://schemas.openxmlformats.org/drawingml/2006/main" xmlns:p="http://schemas.openxmlformats.org/presentationml/2006/main" xmlns:r="http://schemas.openxmlformats.org/officeDocument/2006/relationships">
+<p:sld xmlns:a="http://schemas.openxmlformats.org/drawingml/2006/main" xmlns:r="http://schemas.openxmlformats.org/officeDocument/2006/relationships" xmlns:p="http://schemas.openxmlformats.org/presentationml/2006/main">
   <p:cSld>
     <p:bg>
       <p:bgPr>
@@ -3121,7 +3116,14 @@
         <p:cNvGrpSpPr/>
         <p:nvPr/>
       </p:nvGrpSpPr>
-      <p:grpSpPr/>
+      <p:grpSpPr>
+        <a:xfrm>
+          <a:off x="0" y="0"/>
+          <a:ext cx="0" cy="0"/>
+          <a:chOff x="0" y="0"/>
+          <a:chExt cx="0" cy="0"/>
+        </a:xfrm>
+      </p:grpSpPr>
       <p:sp>
         <p:nvSpPr>
           <p:cNvPr id="2" name="Rectangle 1"/>
@@ -3162,6 +3164,7 @@
           <a:lstStyle/>
           <a:p>
             <a:pPr algn="ctr"/>
+            <a:endParaRPr/>
           </a:p>
         </p:txBody>
       </p:sp>
@@ -3275,6 +3278,7 @@
           <a:lstStyle/>
           <a:p>
             <a:pPr algn="ctr"/>
+            <a:endParaRPr/>
           </a:p>
         </p:txBody>
       </p:sp>
@@ -3353,6 +3357,7 @@
           <a:lstStyle/>
           <a:p>
             <a:pPr algn="ctr"/>
+            <a:endParaRPr/>
           </a:p>
         </p:txBody>
       </p:sp>
@@ -3431,6 +3436,7 @@
           <a:lstStyle/>
           <a:p>
             <a:pPr algn="ctr"/>
+            <a:endParaRPr/>
           </a:p>
         </p:txBody>
       </p:sp>
@@ -3509,6 +3515,7 @@
           <a:lstStyle/>
           <a:p>
             <a:pPr algn="ctr"/>
+            <a:endParaRPr/>
           </a:p>
         </p:txBody>
       </p:sp>
@@ -3587,6 +3594,7 @@
           <a:lstStyle/>
           <a:p>
             <a:pPr algn="ctr"/>
+            <a:endParaRPr/>
           </a:p>
         </p:txBody>
       </p:sp>
@@ -3787,6 +3795,7 @@
           <a:lstStyle/>
           <a:p>
             <a:pPr algn="ctr"/>
+            <a:endParaRPr/>
           </a:p>
         </p:txBody>
       </p:sp>
@@ -3834,7 +3843,7 @@
 </file>
 
 <file path=ppt/slides/slide10.xml><?xml version="1.0" encoding="utf-8"?>
-<p:sld xmlns:a="http://schemas.openxmlformats.org/drawingml/2006/main" xmlns:p="http://schemas.openxmlformats.org/presentationml/2006/main" xmlns:r="http://schemas.openxmlformats.org/officeDocument/2006/relationships">
+<p:sld xmlns:a="http://schemas.openxmlformats.org/drawingml/2006/main" xmlns:r="http://schemas.openxmlformats.org/officeDocument/2006/relationships" xmlns:p="http://schemas.openxmlformats.org/presentationml/2006/main">
   <p:cSld>
     <p:bg>
       <p:bgPr>
@@ -3850,7 +3859,14 @@
         <p:cNvGrpSpPr/>
         <p:nvPr/>
       </p:nvGrpSpPr>
-      <p:grpSpPr/>
+      <p:grpSpPr>
+        <a:xfrm>
+          <a:off x="0" y="0"/>
+          <a:ext cx="0" cy="0"/>
+          <a:chOff x="0" y="0"/>
+          <a:chExt cx="0" cy="0"/>
+        </a:xfrm>
+      </p:grpSpPr>
       <p:sp>
         <p:nvSpPr>
           <p:cNvPr id="2" name="Rectangle 1"/>
@@ -3891,6 +3907,7 @@
           <a:lstStyle/>
           <a:p>
             <a:pPr algn="ctr"/>
+            <a:endParaRPr/>
           </a:p>
         </p:txBody>
       </p:sp>
@@ -3934,6 +3951,7 @@
           <a:lstStyle/>
           <a:p>
             <a:pPr algn="ctr"/>
+            <a:endParaRPr/>
           </a:p>
         </p:txBody>
       </p:sp>
@@ -4047,6 +4065,7 @@
           <a:lstStyle/>
           <a:p>
             <a:pPr algn="ctr"/>
+            <a:endParaRPr/>
           </a:p>
         </p:txBody>
       </p:sp>
@@ -4069,9 +4088,27 @@
                 <a:tableStyleId>{5C22544A-7EE6-4342-B048-85BDC9FD1C3A}</a:tableStyleId>
               </a:tblPr>
               <a:tblGrid>
-                <a:gridCol w="3749040"/>
-                <a:gridCol w="3749040"/>
-                <a:gridCol w="3749040"/>
+                <a:gridCol w="3749040">
+                  <a:extLst>
+                    <a:ext uri="{9D8B030D-6E8A-4147-A177-3AD203B41FA5}">
+                      <a16:colId xmlns:a16="http://schemas.microsoft.com/office/drawing/2014/main" val="20000"/>
+                    </a:ext>
+                  </a:extLst>
+                </a:gridCol>
+                <a:gridCol w="3749040">
+                  <a:extLst>
+                    <a:ext uri="{9D8B030D-6E8A-4147-A177-3AD203B41FA5}">
+                      <a16:colId xmlns:a16="http://schemas.microsoft.com/office/drawing/2014/main" val="20001"/>
+                    </a:ext>
+                  </a:extLst>
+                </a:gridCol>
+                <a:gridCol w="3749040">
+                  <a:extLst>
+                    <a:ext uri="{9D8B030D-6E8A-4147-A177-3AD203B41FA5}">
+                      <a16:colId xmlns:a16="http://schemas.microsoft.com/office/drawing/2014/main" val="20002"/>
+                    </a:ext>
+                  </a:extLst>
+                </a:gridCol>
               </a:tblGrid>
               <a:tr h="399010">
                 <a:tc>
@@ -4143,6 +4180,11 @@
                     </a:solidFill>
                   </a:tcPr>
                 </a:tc>
+                <a:extLst>
+                  <a:ext uri="{0D108BD9-81ED-4DB2-BD59-A6C34878D82A}">
+                    <a16:rowId xmlns:a16="http://schemas.microsoft.com/office/drawing/2014/main" val="10000"/>
+                  </a:ext>
+                </a:extLst>
               </a:tr>
               <a:tr h="399010">
                 <a:tc>
@@ -4214,6 +4256,11 @@
                     </a:solidFill>
                   </a:tcPr>
                 </a:tc>
+                <a:extLst>
+                  <a:ext uri="{0D108BD9-81ED-4DB2-BD59-A6C34878D82A}">
+                    <a16:rowId xmlns:a16="http://schemas.microsoft.com/office/drawing/2014/main" val="10001"/>
+                  </a:ext>
+                </a:extLst>
               </a:tr>
               <a:tr h="399010">
                 <a:tc>
@@ -4285,6 +4332,11 @@
                     </a:solidFill>
                   </a:tcPr>
                 </a:tc>
+                <a:extLst>
+                  <a:ext uri="{0D108BD9-81ED-4DB2-BD59-A6C34878D82A}">
+                    <a16:rowId xmlns:a16="http://schemas.microsoft.com/office/drawing/2014/main" val="10002"/>
+                  </a:ext>
+                </a:extLst>
               </a:tr>
               <a:tr h="399010">
                 <a:tc>
@@ -4356,6 +4408,11 @@
                     </a:solidFill>
                   </a:tcPr>
                 </a:tc>
+                <a:extLst>
+                  <a:ext uri="{0D108BD9-81ED-4DB2-BD59-A6C34878D82A}">
+                    <a16:rowId xmlns:a16="http://schemas.microsoft.com/office/drawing/2014/main" val="10003"/>
+                  </a:ext>
+                </a:extLst>
               </a:tr>
               <a:tr h="399010">
                 <a:tc>
@@ -4427,6 +4484,11 @@
                     </a:solidFill>
                   </a:tcPr>
                 </a:tc>
+                <a:extLst>
+                  <a:ext uri="{0D108BD9-81ED-4DB2-BD59-A6C34878D82A}">
+                    <a16:rowId xmlns:a16="http://schemas.microsoft.com/office/drawing/2014/main" val="10004"/>
+                  </a:ext>
+                </a:extLst>
               </a:tr>
               <a:tr h="399010">
                 <a:tc>
@@ -4498,6 +4560,11 @@
                     </a:solidFill>
                   </a:tcPr>
                 </a:tc>
+                <a:extLst>
+                  <a:ext uri="{0D108BD9-81ED-4DB2-BD59-A6C34878D82A}">
+                    <a16:rowId xmlns:a16="http://schemas.microsoft.com/office/drawing/2014/main" val="10005"/>
+                  </a:ext>
+                </a:extLst>
               </a:tr>
               <a:tr h="399010">
                 <a:tc>
@@ -4569,6 +4636,11 @@
                     </a:solidFill>
                   </a:tcPr>
                 </a:tc>
+                <a:extLst>
+                  <a:ext uri="{0D108BD9-81ED-4DB2-BD59-A6C34878D82A}">
+                    <a16:rowId xmlns:a16="http://schemas.microsoft.com/office/drawing/2014/main" val="10006"/>
+                  </a:ext>
+                </a:extLst>
               </a:tr>
               <a:tr h="399010">
                 <a:tc>
@@ -4640,6 +4712,11 @@
                     </a:solidFill>
                   </a:tcPr>
                 </a:tc>
+                <a:extLst>
+                  <a:ext uri="{0D108BD9-81ED-4DB2-BD59-A6C34878D82A}">
+                    <a16:rowId xmlns:a16="http://schemas.microsoft.com/office/drawing/2014/main" val="10007"/>
+                  </a:ext>
+                </a:extLst>
               </a:tr>
               <a:tr h="399010">
                 <a:tc>
@@ -4711,6 +4788,11 @@
                     </a:solidFill>
                   </a:tcPr>
                 </a:tc>
+                <a:extLst>
+                  <a:ext uri="{0D108BD9-81ED-4DB2-BD59-A6C34878D82A}">
+                    <a16:rowId xmlns:a16="http://schemas.microsoft.com/office/drawing/2014/main" val="10008"/>
+                  </a:ext>
+                </a:extLst>
               </a:tr>
               <a:tr h="399010">
                 <a:tc>
@@ -4782,6 +4864,11 @@
                     </a:solidFill>
                   </a:tcPr>
                 </a:tc>
+                <a:extLst>
+                  <a:ext uri="{0D108BD9-81ED-4DB2-BD59-A6C34878D82A}">
+                    <a16:rowId xmlns:a16="http://schemas.microsoft.com/office/drawing/2014/main" val="10009"/>
+                  </a:ext>
+                </a:extLst>
               </a:tr>
               <a:tr h="399020">
                 <a:tc>
@@ -4853,6 +4940,11 @@
                     </a:solidFill>
                   </a:tcPr>
                 </a:tc>
+                <a:extLst>
+                  <a:ext uri="{0D108BD9-81ED-4DB2-BD59-A6C34878D82A}">
+                    <a16:rowId xmlns:a16="http://schemas.microsoft.com/office/drawing/2014/main" val="10010"/>
+                  </a:ext>
+                </a:extLst>
               </a:tr>
             </a:tbl>
           </a:graphicData>
@@ -4867,7 +4959,7 @@
 </file>
 
 <file path=ppt/slides/slide11.xml><?xml version="1.0" encoding="utf-8"?>
-<p:sld xmlns:a="http://schemas.openxmlformats.org/drawingml/2006/main" xmlns:p="http://schemas.openxmlformats.org/presentationml/2006/main" xmlns:r="http://schemas.openxmlformats.org/officeDocument/2006/relationships">
+<p:sld xmlns:a="http://schemas.openxmlformats.org/drawingml/2006/main" xmlns:r="http://schemas.openxmlformats.org/officeDocument/2006/relationships" xmlns:p="http://schemas.openxmlformats.org/presentationml/2006/main">
   <p:cSld>
     <p:bg>
       <p:bgPr>
@@ -4883,7 +4975,14 @@
         <p:cNvGrpSpPr/>
         <p:nvPr/>
       </p:nvGrpSpPr>
-      <p:grpSpPr/>
+      <p:grpSpPr>
+        <a:xfrm>
+          <a:off x="0" y="0"/>
+          <a:ext cx="0" cy="0"/>
+          <a:chOff x="0" y="0"/>
+          <a:chExt cx="0" cy="0"/>
+        </a:xfrm>
+      </p:grpSpPr>
       <p:sp>
         <p:nvSpPr>
           <p:cNvPr id="2" name="Rectangle 1"/>
@@ -4924,6 +5023,7 @@
           <a:lstStyle/>
           <a:p>
             <a:pPr algn="ctr"/>
+            <a:endParaRPr/>
           </a:p>
         </p:txBody>
       </p:sp>
@@ -5041,7 +5141,7 @@
 </file>
 
 <file path=ppt/slides/slide12.xml><?xml version="1.0" encoding="utf-8"?>
-<p:sld xmlns:a="http://schemas.openxmlformats.org/drawingml/2006/main" xmlns:p="http://schemas.openxmlformats.org/presentationml/2006/main" xmlns:r="http://schemas.openxmlformats.org/officeDocument/2006/relationships">
+<p:sld xmlns:a="http://schemas.openxmlformats.org/drawingml/2006/main" xmlns:r="http://schemas.openxmlformats.org/officeDocument/2006/relationships" xmlns:p="http://schemas.openxmlformats.org/presentationml/2006/main">
   <p:cSld>
     <p:bg>
       <p:bgPr>
@@ -5057,7 +5157,14 @@
         <p:cNvGrpSpPr/>
         <p:nvPr/>
       </p:nvGrpSpPr>
-      <p:grpSpPr/>
+      <p:grpSpPr>
+        <a:xfrm>
+          <a:off x="0" y="0"/>
+          <a:ext cx="0" cy="0"/>
+          <a:chOff x="0" y="0"/>
+          <a:chExt cx="0" cy="0"/>
+        </a:xfrm>
+      </p:grpSpPr>
       <p:sp>
         <p:nvSpPr>
           <p:cNvPr id="2" name="Rectangle 1"/>
@@ -5098,6 +5205,7 @@
           <a:lstStyle/>
           <a:p>
             <a:pPr algn="ctr"/>
+            <a:endParaRPr/>
           </a:p>
         </p:txBody>
       </p:sp>
@@ -5141,6 +5249,7 @@
           <a:lstStyle/>
           <a:p>
             <a:pPr algn="ctr"/>
+            <a:endParaRPr/>
           </a:p>
         </p:txBody>
       </p:sp>
@@ -5254,6 +5363,7 @@
           <a:lstStyle/>
           <a:p>
             <a:pPr algn="ctr"/>
+            <a:endParaRPr/>
           </a:p>
         </p:txBody>
       </p:sp>
@@ -5297,6 +5407,7 @@
           <a:lstStyle/>
           <a:p>
             <a:pPr algn="ctr"/>
+            <a:endParaRPr/>
           </a:p>
         </p:txBody>
       </p:sp>
@@ -5377,6 +5488,7 @@
           <a:lstStyle/>
           <a:p>
             <a:pPr algn="ctr"/>
+            <a:endParaRPr/>
           </a:p>
         </p:txBody>
       </p:sp>
@@ -5490,6 +5602,7 @@
           <a:lstStyle/>
           <a:p>
             <a:pPr algn="ctr"/>
+            <a:endParaRPr/>
           </a:p>
         </p:txBody>
       </p:sp>
@@ -5570,6 +5683,7 @@
           <a:lstStyle/>
           <a:p>
             <a:pPr algn="ctr"/>
+            <a:endParaRPr/>
           </a:p>
         </p:txBody>
       </p:sp>
@@ -5683,6 +5797,7 @@
           <a:lstStyle/>
           <a:p>
             <a:pPr algn="ctr"/>
+            <a:endParaRPr/>
           </a:p>
         </p:txBody>
       </p:sp>
@@ -5763,6 +5878,7 @@
           <a:lstStyle/>
           <a:p>
             <a:pPr algn="ctr"/>
+            <a:endParaRPr/>
           </a:p>
         </p:txBody>
       </p:sp>
@@ -5876,6 +5992,7 @@
           <a:lstStyle/>
           <a:p>
             <a:pPr algn="ctr"/>
+            <a:endParaRPr/>
           </a:p>
         </p:txBody>
       </p:sp>
@@ -5956,6 +6073,7 @@
           <a:lstStyle/>
           <a:p>
             <a:pPr algn="ctr"/>
+            <a:endParaRPr/>
           </a:p>
         </p:txBody>
       </p:sp>
@@ -6069,6 +6187,7 @@
           <a:lstStyle/>
           <a:p>
             <a:pPr algn="ctr"/>
+            <a:endParaRPr/>
           </a:p>
         </p:txBody>
       </p:sp>
@@ -6149,6 +6268,7 @@
           <a:lstStyle/>
           <a:p>
             <a:pPr algn="ctr"/>
+            <a:endParaRPr/>
           </a:p>
         </p:txBody>
       </p:sp>
@@ -6262,6 +6382,7 @@
           <a:lstStyle/>
           <a:p>
             <a:pPr algn="ctr"/>
+            <a:endParaRPr/>
           </a:p>
         </p:txBody>
       </p:sp>
@@ -6342,6 +6463,7 @@
           <a:lstStyle/>
           <a:p>
             <a:pPr algn="ctr"/>
+            <a:endParaRPr/>
           </a:p>
         </p:txBody>
       </p:sp>
@@ -6700,7 +6822,7 @@
 </file>
 
 <file path=ppt/slides/slide13.xml><?xml version="1.0" encoding="utf-8"?>
-<p:sld xmlns:a="http://schemas.openxmlformats.org/drawingml/2006/main" xmlns:p="http://schemas.openxmlformats.org/presentationml/2006/main" xmlns:r="http://schemas.openxmlformats.org/officeDocument/2006/relationships">
+<p:sld xmlns:a="http://schemas.openxmlformats.org/drawingml/2006/main" xmlns:r="http://schemas.openxmlformats.org/officeDocument/2006/relationships" xmlns:p="http://schemas.openxmlformats.org/presentationml/2006/main">
   <p:cSld>
     <p:bg>
       <p:bgPr>
@@ -6716,7 +6838,14 @@
         <p:cNvGrpSpPr/>
         <p:nvPr/>
       </p:nvGrpSpPr>
-      <p:grpSpPr/>
+      <p:grpSpPr>
+        <a:xfrm>
+          <a:off x="0" y="0"/>
+          <a:ext cx="0" cy="0"/>
+          <a:chOff x="0" y="0"/>
+          <a:chExt cx="0" cy="0"/>
+        </a:xfrm>
+      </p:grpSpPr>
       <p:sp>
         <p:nvSpPr>
           <p:cNvPr id="2" name="Rectangle 1"/>
@@ -6757,6 +6886,7 @@
           <a:lstStyle/>
           <a:p>
             <a:pPr algn="ctr"/>
+            <a:endParaRPr/>
           </a:p>
         </p:txBody>
       </p:sp>
@@ -6800,6 +6930,7 @@
           <a:lstStyle/>
           <a:p>
             <a:pPr algn="ctr"/>
+            <a:endParaRPr/>
           </a:p>
         </p:txBody>
       </p:sp>
@@ -6913,6 +7044,7 @@
           <a:lstStyle/>
           <a:p>
             <a:pPr algn="ctr"/>
+            <a:endParaRPr/>
           </a:p>
         </p:txBody>
       </p:sp>
@@ -6935,11 +7067,41 @@
                 <a:tableStyleId>{5C22544A-7EE6-4342-B048-85BDC9FD1C3A}</a:tableStyleId>
               </a:tblPr>
               <a:tblGrid>
-                <a:gridCol w="2322576"/>
-                <a:gridCol w="2322576"/>
-                <a:gridCol w="2322576"/>
-                <a:gridCol w="2322576"/>
-                <a:gridCol w="2322576"/>
+                <a:gridCol w="2322576">
+                  <a:extLst>
+                    <a:ext uri="{9D8B030D-6E8A-4147-A177-3AD203B41FA5}">
+                      <a16:colId xmlns:a16="http://schemas.microsoft.com/office/drawing/2014/main" val="20000"/>
+                    </a:ext>
+                  </a:extLst>
+                </a:gridCol>
+                <a:gridCol w="2322576">
+                  <a:extLst>
+                    <a:ext uri="{9D8B030D-6E8A-4147-A177-3AD203B41FA5}">
+                      <a16:colId xmlns:a16="http://schemas.microsoft.com/office/drawing/2014/main" val="20001"/>
+                    </a:ext>
+                  </a:extLst>
+                </a:gridCol>
+                <a:gridCol w="2322576">
+                  <a:extLst>
+                    <a:ext uri="{9D8B030D-6E8A-4147-A177-3AD203B41FA5}">
+                      <a16:colId xmlns:a16="http://schemas.microsoft.com/office/drawing/2014/main" val="20002"/>
+                    </a:ext>
+                  </a:extLst>
+                </a:gridCol>
+                <a:gridCol w="2322576">
+                  <a:extLst>
+                    <a:ext uri="{9D8B030D-6E8A-4147-A177-3AD203B41FA5}">
+                      <a16:colId xmlns:a16="http://schemas.microsoft.com/office/drawing/2014/main" val="20003"/>
+                    </a:ext>
+                  </a:extLst>
+                </a:gridCol>
+                <a:gridCol w="2322576">
+                  <a:extLst>
+                    <a:ext uri="{9D8B030D-6E8A-4147-A177-3AD203B41FA5}">
+                      <a16:colId xmlns:a16="http://schemas.microsoft.com/office/drawing/2014/main" val="20004"/>
+                    </a:ext>
+                  </a:extLst>
+                </a:gridCol>
               </a:tblGrid>
               <a:tr h="386861">
                 <a:tc>
@@ -7057,6 +7219,11 @@
                     </a:solidFill>
                   </a:tcPr>
                 </a:tc>
+                <a:extLst>
+                  <a:ext uri="{0D108BD9-81ED-4DB2-BD59-A6C34878D82A}">
+                    <a16:rowId xmlns:a16="http://schemas.microsoft.com/office/drawing/2014/main" val="10000"/>
+                  </a:ext>
+                </a:extLst>
               </a:tr>
               <a:tr h="386861">
                 <a:tc>
@@ -7174,6 +7341,11 @@
                     </a:solidFill>
                   </a:tcPr>
                 </a:tc>
+                <a:extLst>
+                  <a:ext uri="{0D108BD9-81ED-4DB2-BD59-A6C34878D82A}">
+                    <a16:rowId xmlns:a16="http://schemas.microsoft.com/office/drawing/2014/main" val="10001"/>
+                  </a:ext>
+                </a:extLst>
               </a:tr>
               <a:tr h="386861">
                 <a:tc>
@@ -7291,6 +7463,11 @@
                     </a:solidFill>
                   </a:tcPr>
                 </a:tc>
+                <a:extLst>
+                  <a:ext uri="{0D108BD9-81ED-4DB2-BD59-A6C34878D82A}">
+                    <a16:rowId xmlns:a16="http://schemas.microsoft.com/office/drawing/2014/main" val="10002"/>
+                  </a:ext>
+                </a:extLst>
               </a:tr>
               <a:tr h="386861">
                 <a:tc>
@@ -7408,6 +7585,11 @@
                     </a:solidFill>
                   </a:tcPr>
                 </a:tc>
+                <a:extLst>
+                  <a:ext uri="{0D108BD9-81ED-4DB2-BD59-A6C34878D82A}">
+                    <a16:rowId xmlns:a16="http://schemas.microsoft.com/office/drawing/2014/main" val="10003"/>
+                  </a:ext>
+                </a:extLst>
               </a:tr>
               <a:tr h="386861">
                 <a:tc>
@@ -7525,6 +7707,11 @@
                     </a:solidFill>
                   </a:tcPr>
                 </a:tc>
+                <a:extLst>
+                  <a:ext uri="{0D108BD9-81ED-4DB2-BD59-A6C34878D82A}">
+                    <a16:rowId xmlns:a16="http://schemas.microsoft.com/office/drawing/2014/main" val="10004"/>
+                  </a:ext>
+                </a:extLst>
               </a:tr>
               <a:tr h="386861">
                 <a:tc>
@@ -7642,6 +7829,11 @@
                     </a:solidFill>
                   </a:tcPr>
                 </a:tc>
+                <a:extLst>
+                  <a:ext uri="{0D108BD9-81ED-4DB2-BD59-A6C34878D82A}">
+                    <a16:rowId xmlns:a16="http://schemas.microsoft.com/office/drawing/2014/main" val="10005"/>
+                  </a:ext>
+                </a:extLst>
               </a:tr>
               <a:tr h="386861">
                 <a:tc>
@@ -7759,6 +7951,11 @@
                     </a:solidFill>
                   </a:tcPr>
                 </a:tc>
+                <a:extLst>
+                  <a:ext uri="{0D108BD9-81ED-4DB2-BD59-A6C34878D82A}">
+                    <a16:rowId xmlns:a16="http://schemas.microsoft.com/office/drawing/2014/main" val="10006"/>
+                  </a:ext>
+                </a:extLst>
               </a:tr>
               <a:tr h="386861">
                 <a:tc>
@@ -7876,6 +8073,11 @@
                     </a:solidFill>
                   </a:tcPr>
                 </a:tc>
+                <a:extLst>
+                  <a:ext uri="{0D108BD9-81ED-4DB2-BD59-A6C34878D82A}">
+                    <a16:rowId xmlns:a16="http://schemas.microsoft.com/office/drawing/2014/main" val="10007"/>
+                  </a:ext>
+                </a:extLst>
               </a:tr>
               <a:tr h="386861">
                 <a:tc>
@@ -7993,6 +8195,11 @@
                     </a:solidFill>
                   </a:tcPr>
                 </a:tc>
+                <a:extLst>
+                  <a:ext uri="{0D108BD9-81ED-4DB2-BD59-A6C34878D82A}">
+                    <a16:rowId xmlns:a16="http://schemas.microsoft.com/office/drawing/2014/main" val="10008"/>
+                  </a:ext>
+                </a:extLst>
               </a:tr>
               <a:tr h="386861">
                 <a:tc>
@@ -8110,6 +8317,11 @@
                     </a:solidFill>
                   </a:tcPr>
                 </a:tc>
+                <a:extLst>
+                  <a:ext uri="{0D108BD9-81ED-4DB2-BD59-A6C34878D82A}">
+                    <a16:rowId xmlns:a16="http://schemas.microsoft.com/office/drawing/2014/main" val="10009"/>
+                  </a:ext>
+                </a:extLst>
               </a:tr>
               <a:tr h="386861">
                 <a:tc>
@@ -8227,6 +8439,11 @@
                     </a:solidFill>
                   </a:tcPr>
                 </a:tc>
+                <a:extLst>
+                  <a:ext uri="{0D108BD9-81ED-4DB2-BD59-A6C34878D82A}">
+                    <a16:rowId xmlns:a16="http://schemas.microsoft.com/office/drawing/2014/main" val="10010"/>
+                  </a:ext>
+                </a:extLst>
               </a:tr>
               <a:tr h="386861">
                 <a:tc>
@@ -8344,6 +8561,11 @@
                     </a:solidFill>
                   </a:tcPr>
                 </a:tc>
+                <a:extLst>
+                  <a:ext uri="{0D108BD9-81ED-4DB2-BD59-A6C34878D82A}">
+                    <a16:rowId xmlns:a16="http://schemas.microsoft.com/office/drawing/2014/main" val="10011"/>
+                  </a:ext>
+                </a:extLst>
               </a:tr>
               <a:tr h="386868">
                 <a:tc>
@@ -8461,6 +8683,11 @@
                     </a:solidFill>
                   </a:tcPr>
                 </a:tc>
+                <a:extLst>
+                  <a:ext uri="{0D108BD9-81ED-4DB2-BD59-A6C34878D82A}">
+                    <a16:rowId xmlns:a16="http://schemas.microsoft.com/office/drawing/2014/main" val="10012"/>
+                  </a:ext>
+                </a:extLst>
               </a:tr>
             </a:tbl>
           </a:graphicData>
@@ -8475,7 +8702,7 @@
 </file>
 
 <file path=ppt/slides/slide14.xml><?xml version="1.0" encoding="utf-8"?>
-<p:sld xmlns:a="http://schemas.openxmlformats.org/drawingml/2006/main" xmlns:p="http://schemas.openxmlformats.org/presentationml/2006/main" xmlns:r="http://schemas.openxmlformats.org/officeDocument/2006/relationships">
+<p:sld xmlns:a="http://schemas.openxmlformats.org/drawingml/2006/main" xmlns:r="http://schemas.openxmlformats.org/officeDocument/2006/relationships" xmlns:p="http://schemas.openxmlformats.org/presentationml/2006/main">
   <p:cSld>
     <p:bg>
       <p:bgPr>
@@ -8491,7 +8718,14 @@
         <p:cNvGrpSpPr/>
         <p:nvPr/>
       </p:nvGrpSpPr>
-      <p:grpSpPr/>
+      <p:grpSpPr>
+        <a:xfrm>
+          <a:off x="0" y="0"/>
+          <a:ext cx="0" cy="0"/>
+          <a:chOff x="0" y="0"/>
+          <a:chExt cx="0" cy="0"/>
+        </a:xfrm>
+      </p:grpSpPr>
       <p:sp>
         <p:nvSpPr>
           <p:cNvPr id="2" name="Rectangle 1"/>
@@ -8532,6 +8766,7 @@
           <a:lstStyle/>
           <a:p>
             <a:pPr algn="ctr"/>
+            <a:endParaRPr/>
           </a:p>
         </p:txBody>
       </p:sp>
@@ -8649,7 +8884,7 @@
 </file>
 
 <file path=ppt/slides/slide15.xml><?xml version="1.0" encoding="utf-8"?>
-<p:sld xmlns:a="http://schemas.openxmlformats.org/drawingml/2006/main" xmlns:p="http://schemas.openxmlformats.org/presentationml/2006/main" xmlns:r="http://schemas.openxmlformats.org/officeDocument/2006/relationships">
+<p:sld xmlns:a="http://schemas.openxmlformats.org/drawingml/2006/main" xmlns:r="http://schemas.openxmlformats.org/officeDocument/2006/relationships" xmlns:p="http://schemas.openxmlformats.org/presentationml/2006/main">
   <p:cSld>
     <p:bg>
       <p:bgPr>
@@ -8665,7 +8900,14 @@
         <p:cNvGrpSpPr/>
         <p:nvPr/>
       </p:nvGrpSpPr>
-      <p:grpSpPr/>
+      <p:grpSpPr>
+        <a:xfrm>
+          <a:off x="0" y="0"/>
+          <a:ext cx="0" cy="0"/>
+          <a:chOff x="0" y="0"/>
+          <a:chExt cx="0" cy="0"/>
+        </a:xfrm>
+      </p:grpSpPr>
       <p:sp>
         <p:nvSpPr>
           <p:cNvPr id="2" name="Rectangle 1"/>
@@ -8706,6 +8948,7 @@
           <a:lstStyle/>
           <a:p>
             <a:pPr algn="ctr"/>
+            <a:endParaRPr/>
           </a:p>
         </p:txBody>
       </p:sp>
@@ -8749,6 +8992,7 @@
           <a:lstStyle/>
           <a:p>
             <a:pPr algn="ctr"/>
+            <a:endParaRPr/>
           </a:p>
         </p:txBody>
       </p:sp>
@@ -8862,6 +9106,7 @@
           <a:lstStyle/>
           <a:p>
             <a:pPr algn="ctr"/>
+            <a:endParaRPr/>
           </a:p>
         </p:txBody>
       </p:sp>
@@ -8884,11 +9129,41 @@
                 <a:tableStyleId>{5C22544A-7EE6-4342-B048-85BDC9FD1C3A}</a:tableStyleId>
               </a:tblPr>
               <a:tblGrid>
-                <a:gridCol w="2322576"/>
-                <a:gridCol w="2322576"/>
-                <a:gridCol w="2322576"/>
-                <a:gridCol w="2322576"/>
-                <a:gridCol w="2322576"/>
+                <a:gridCol w="2322576">
+                  <a:extLst>
+                    <a:ext uri="{9D8B030D-6E8A-4147-A177-3AD203B41FA5}">
+                      <a16:colId xmlns:a16="http://schemas.microsoft.com/office/drawing/2014/main" val="20000"/>
+                    </a:ext>
+                  </a:extLst>
+                </a:gridCol>
+                <a:gridCol w="2322576">
+                  <a:extLst>
+                    <a:ext uri="{9D8B030D-6E8A-4147-A177-3AD203B41FA5}">
+                      <a16:colId xmlns:a16="http://schemas.microsoft.com/office/drawing/2014/main" val="20001"/>
+                    </a:ext>
+                  </a:extLst>
+                </a:gridCol>
+                <a:gridCol w="2322576">
+                  <a:extLst>
+                    <a:ext uri="{9D8B030D-6E8A-4147-A177-3AD203B41FA5}">
+                      <a16:colId xmlns:a16="http://schemas.microsoft.com/office/drawing/2014/main" val="20002"/>
+                    </a:ext>
+                  </a:extLst>
+                </a:gridCol>
+                <a:gridCol w="2322576">
+                  <a:extLst>
+                    <a:ext uri="{9D8B030D-6E8A-4147-A177-3AD203B41FA5}">
+                      <a16:colId xmlns:a16="http://schemas.microsoft.com/office/drawing/2014/main" val="20003"/>
+                    </a:ext>
+                  </a:extLst>
+                </a:gridCol>
+                <a:gridCol w="2322576">
+                  <a:extLst>
+                    <a:ext uri="{9D8B030D-6E8A-4147-A177-3AD203B41FA5}">
+                      <a16:colId xmlns:a16="http://schemas.microsoft.com/office/drawing/2014/main" val="20004"/>
+                    </a:ext>
+                  </a:extLst>
+                </a:gridCol>
               </a:tblGrid>
               <a:tr h="448887">
                 <a:tc>
@@ -9006,6 +9281,11 @@
                     </a:solidFill>
                   </a:tcPr>
                 </a:tc>
+                <a:extLst>
+                  <a:ext uri="{0D108BD9-81ED-4DB2-BD59-A6C34878D82A}">
+                    <a16:rowId xmlns:a16="http://schemas.microsoft.com/office/drawing/2014/main" val="10000"/>
+                  </a:ext>
+                </a:extLst>
               </a:tr>
               <a:tr h="448887">
                 <a:tc>
@@ -9123,6 +9403,11 @@
                     </a:solidFill>
                   </a:tcPr>
                 </a:tc>
+                <a:extLst>
+                  <a:ext uri="{0D108BD9-81ED-4DB2-BD59-A6C34878D82A}">
+                    <a16:rowId xmlns:a16="http://schemas.microsoft.com/office/drawing/2014/main" val="10001"/>
+                  </a:ext>
+                </a:extLst>
               </a:tr>
               <a:tr h="448887">
                 <a:tc>
@@ -9240,6 +9525,11 @@
                     </a:solidFill>
                   </a:tcPr>
                 </a:tc>
+                <a:extLst>
+                  <a:ext uri="{0D108BD9-81ED-4DB2-BD59-A6C34878D82A}">
+                    <a16:rowId xmlns:a16="http://schemas.microsoft.com/office/drawing/2014/main" val="10002"/>
+                  </a:ext>
+                </a:extLst>
               </a:tr>
               <a:tr h="448887">
                 <a:tc>
@@ -9357,6 +9647,11 @@
                     </a:solidFill>
                   </a:tcPr>
                 </a:tc>
+                <a:extLst>
+                  <a:ext uri="{0D108BD9-81ED-4DB2-BD59-A6C34878D82A}">
+                    <a16:rowId xmlns:a16="http://schemas.microsoft.com/office/drawing/2014/main" val="10003"/>
+                  </a:ext>
+                </a:extLst>
               </a:tr>
               <a:tr h="448887">
                 <a:tc>
@@ -9474,6 +9769,11 @@
                     </a:solidFill>
                   </a:tcPr>
                 </a:tc>
+                <a:extLst>
+                  <a:ext uri="{0D108BD9-81ED-4DB2-BD59-A6C34878D82A}">
+                    <a16:rowId xmlns:a16="http://schemas.microsoft.com/office/drawing/2014/main" val="10004"/>
+                  </a:ext>
+                </a:extLst>
               </a:tr>
               <a:tr h="448887">
                 <a:tc>
@@ -9591,6 +9891,11 @@
                     </a:solidFill>
                   </a:tcPr>
                 </a:tc>
+                <a:extLst>
+                  <a:ext uri="{0D108BD9-81ED-4DB2-BD59-A6C34878D82A}">
+                    <a16:rowId xmlns:a16="http://schemas.microsoft.com/office/drawing/2014/main" val="10005"/>
+                  </a:ext>
+                </a:extLst>
               </a:tr>
               <a:tr h="448887">
                 <a:tc>
@@ -9708,6 +10013,11 @@
                     </a:solidFill>
                   </a:tcPr>
                 </a:tc>
+                <a:extLst>
+                  <a:ext uri="{0D108BD9-81ED-4DB2-BD59-A6C34878D82A}">
+                    <a16:rowId xmlns:a16="http://schemas.microsoft.com/office/drawing/2014/main" val="10006"/>
+                  </a:ext>
+                </a:extLst>
               </a:tr>
               <a:tr h="448887">
                 <a:tc>
@@ -9825,6 +10135,11 @@
                     </a:solidFill>
                   </a:tcPr>
                 </a:tc>
+                <a:extLst>
+                  <a:ext uri="{0D108BD9-81ED-4DB2-BD59-A6C34878D82A}">
+                    <a16:rowId xmlns:a16="http://schemas.microsoft.com/office/drawing/2014/main" val="10007"/>
+                  </a:ext>
+                </a:extLst>
               </a:tr>
               <a:tr h="448887">
                 <a:tc>
@@ -9942,6 +10257,11 @@
                     </a:solidFill>
                   </a:tcPr>
                 </a:tc>
+                <a:extLst>
+                  <a:ext uri="{0D108BD9-81ED-4DB2-BD59-A6C34878D82A}">
+                    <a16:rowId xmlns:a16="http://schemas.microsoft.com/office/drawing/2014/main" val="10008"/>
+                  </a:ext>
+                </a:extLst>
               </a:tr>
               <a:tr h="448887">
                 <a:tc>
@@ -10059,6 +10379,11 @@
                     </a:solidFill>
                   </a:tcPr>
                 </a:tc>
+                <a:extLst>
+                  <a:ext uri="{0D108BD9-81ED-4DB2-BD59-A6C34878D82A}">
+                    <a16:rowId xmlns:a16="http://schemas.microsoft.com/office/drawing/2014/main" val="10009"/>
+                  </a:ext>
+                </a:extLst>
               </a:tr>
               <a:tr h="448890">
                 <a:tc>
@@ -10176,6 +10501,11 @@
                     </a:solidFill>
                   </a:tcPr>
                 </a:tc>
+                <a:extLst>
+                  <a:ext uri="{0D108BD9-81ED-4DB2-BD59-A6C34878D82A}">
+                    <a16:rowId xmlns:a16="http://schemas.microsoft.com/office/drawing/2014/main" val="10010"/>
+                  </a:ext>
+                </a:extLst>
               </a:tr>
             </a:tbl>
           </a:graphicData>
@@ -10190,7 +10520,7 @@
 </file>
 
 <file path=ppt/slides/slide16.xml><?xml version="1.0" encoding="utf-8"?>
-<p:sld xmlns:a="http://schemas.openxmlformats.org/drawingml/2006/main" xmlns:p="http://schemas.openxmlformats.org/presentationml/2006/main" xmlns:r="http://schemas.openxmlformats.org/officeDocument/2006/relationships">
+<p:sld xmlns:a="http://schemas.openxmlformats.org/drawingml/2006/main" xmlns:r="http://schemas.openxmlformats.org/officeDocument/2006/relationships" xmlns:p="http://schemas.openxmlformats.org/presentationml/2006/main">
   <p:cSld>
     <p:bg>
       <p:bgPr>
@@ -10206,7 +10536,14 @@
         <p:cNvGrpSpPr/>
         <p:nvPr/>
       </p:nvGrpSpPr>
-      <p:grpSpPr/>
+      <p:grpSpPr>
+        <a:xfrm>
+          <a:off x="0" y="0"/>
+          <a:ext cx="0" cy="0"/>
+          <a:chOff x="0" y="0"/>
+          <a:chExt cx="0" cy="0"/>
+        </a:xfrm>
+      </p:grpSpPr>
       <p:sp>
         <p:nvSpPr>
           <p:cNvPr id="2" name="Rectangle 1"/>
@@ -10247,6 +10584,7 @@
           <a:lstStyle/>
           <a:p>
             <a:pPr algn="ctr"/>
+            <a:endParaRPr/>
           </a:p>
         </p:txBody>
       </p:sp>
@@ -10290,6 +10628,7 @@
           <a:lstStyle/>
           <a:p>
             <a:pPr algn="ctr"/>
+            <a:endParaRPr/>
           </a:p>
         </p:txBody>
       </p:sp>
@@ -10403,6 +10742,7 @@
           <a:lstStyle/>
           <a:p>
             <a:pPr algn="ctr"/>
+            <a:endParaRPr/>
           </a:p>
         </p:txBody>
       </p:sp>
@@ -10446,6 +10786,7 @@
           <a:lstStyle/>
           <a:p>
             <a:pPr algn="ctr"/>
+            <a:endParaRPr/>
           </a:p>
         </p:txBody>
       </p:sp>
@@ -10489,6 +10830,7 @@
           <a:lstStyle/>
           <a:p>
             <a:pPr algn="ctr"/>
+            <a:endParaRPr/>
           </a:p>
         </p:txBody>
       </p:sp>
@@ -10608,6 +10950,7 @@
           <a:lstStyle/>
           <a:p>
             <a:pPr algn="ctr"/>
+            <a:endParaRPr/>
           </a:p>
         </p:txBody>
       </p:sp>
@@ -10651,6 +10994,7 @@
           <a:lstStyle/>
           <a:p>
             <a:pPr algn="ctr"/>
+            <a:endParaRPr/>
           </a:p>
         </p:txBody>
       </p:sp>
@@ -10768,6 +11112,7 @@
           <a:lstStyle/>
           <a:p>
             <a:pPr algn="ctr"/>
+            <a:endParaRPr/>
           </a:p>
         </p:txBody>
       </p:sp>
@@ -10811,6 +11156,7 @@
           <a:lstStyle/>
           <a:p>
             <a:pPr algn="ctr"/>
+            <a:endParaRPr/>
           </a:p>
         </p:txBody>
       </p:sp>
@@ -10930,6 +11276,7 @@
           <a:lstStyle/>
           <a:p>
             <a:pPr algn="ctr"/>
+            <a:endParaRPr/>
           </a:p>
         </p:txBody>
       </p:sp>
@@ -10973,6 +11320,7 @@
           <a:lstStyle/>
           <a:p>
             <a:pPr algn="ctr"/>
+            <a:endParaRPr/>
           </a:p>
         </p:txBody>
       </p:sp>
@@ -11060,7 +11408,7 @@
 </file>
 
 <file path=ppt/slides/slide17.xml><?xml version="1.0" encoding="utf-8"?>
-<p:sld xmlns:a="http://schemas.openxmlformats.org/drawingml/2006/main" xmlns:p="http://schemas.openxmlformats.org/presentationml/2006/main" xmlns:r="http://schemas.openxmlformats.org/officeDocument/2006/relationships">
+<p:sld xmlns:a="http://schemas.openxmlformats.org/drawingml/2006/main" xmlns:r="http://schemas.openxmlformats.org/officeDocument/2006/relationships" xmlns:p="http://schemas.openxmlformats.org/presentationml/2006/main">
   <p:cSld>
     <p:bg>
       <p:bgPr>
@@ -11076,7 +11424,14 @@
         <p:cNvGrpSpPr/>
         <p:nvPr/>
       </p:nvGrpSpPr>
-      <p:grpSpPr/>
+      <p:grpSpPr>
+        <a:xfrm>
+          <a:off x="0" y="0"/>
+          <a:ext cx="0" cy="0"/>
+          <a:chOff x="0" y="0"/>
+          <a:chExt cx="0" cy="0"/>
+        </a:xfrm>
+      </p:grpSpPr>
       <p:sp>
         <p:nvSpPr>
           <p:cNvPr id="2" name="Rectangle 1"/>
@@ -11117,6 +11472,7 @@
           <a:lstStyle/>
           <a:p>
             <a:pPr algn="ctr"/>
+            <a:endParaRPr/>
           </a:p>
         </p:txBody>
       </p:sp>
@@ -11160,6 +11516,7 @@
           <a:lstStyle/>
           <a:p>
             <a:pPr algn="ctr"/>
+            <a:endParaRPr/>
           </a:p>
         </p:txBody>
       </p:sp>
@@ -11273,6 +11630,7 @@
           <a:lstStyle/>
           <a:p>
             <a:pPr algn="ctr"/>
+            <a:endParaRPr/>
           </a:p>
         </p:txBody>
       </p:sp>
@@ -11316,6 +11674,7 @@
           <a:lstStyle/>
           <a:p>
             <a:pPr algn="ctr"/>
+            <a:endParaRPr/>
           </a:p>
         </p:txBody>
       </p:sp>
@@ -11359,6 +11718,7 @@
           <a:lstStyle/>
           <a:p>
             <a:pPr algn="ctr"/>
+            <a:endParaRPr/>
           </a:p>
         </p:txBody>
       </p:sp>
@@ -11371,7 +11731,7 @@
         <p:spPr>
           <a:xfrm>
             <a:off x="502920" y="1234440"/>
-            <a:ext cx="5303520" cy="411480"/>
+            <a:ext cx="5303520" cy="276999"/>
           </a:xfrm>
           <a:prstGeom prst="rect">
             <a:avLst/>
@@ -11386,13 +11746,13 @@
           <a:p>
             <a:pPr algn="l"/>
             <a:r>
-              <a:rPr sz="1200" b="1" i="0">
+              <a:rPr sz="1200" b="1" i="0" dirty="0">
                 <a:solidFill>
                   <a:srgbClr val="FFFFFF"/>
                 </a:solidFill>
                 <a:latin typeface="Calibri"/>
               </a:rPr>
-              <a:t>❌  SEBELUM PERBAIKAN</a:t>
+              <a:t> SEBELUM PERBAIKAN</a:t>
             </a:r>
           </a:p>
         </p:txBody>
@@ -11556,6 +11916,7 @@
           <a:lstStyle/>
           <a:p>
             <a:pPr algn="ctr"/>
+            <a:endParaRPr/>
           </a:p>
         </p:txBody>
       </p:sp>
@@ -11599,6 +11960,7 @@
           <a:lstStyle/>
           <a:p>
             <a:pPr algn="ctr"/>
+            <a:endParaRPr/>
           </a:p>
         </p:txBody>
       </p:sp>
@@ -11611,7 +11973,7 @@
         <p:spPr>
           <a:xfrm>
             <a:off x="6446520" y="1234440"/>
-            <a:ext cx="5303520" cy="411480"/>
+            <a:ext cx="5303520" cy="276999"/>
           </a:xfrm>
           <a:prstGeom prst="rect">
             <a:avLst/>
@@ -11626,13 +11988,13 @@
           <a:p>
             <a:pPr algn="l"/>
             <a:r>
-              <a:rPr sz="1200" b="1" i="0">
+              <a:rPr sz="1200" b="1" i="0" dirty="0">
                 <a:solidFill>
                   <a:srgbClr val="FFFFFF"/>
                 </a:solidFill>
                 <a:latin typeface="Calibri"/>
               </a:rPr>
-              <a:t>✅  SESUDAH PERBAIKAN</a:t>
+              <a:t>SESUDAH PERBAIKAN</a:t>
             </a:r>
           </a:p>
         </p:txBody>
@@ -11764,7 +12126,7 @@
         </p:nvSpPr>
         <p:spPr>
           <a:xfrm>
-            <a:off x="5623560" y="3474720"/>
+            <a:off x="5800896" y="3474720"/>
             <a:ext cx="640080" cy="640080"/>
           </a:xfrm>
           <a:prstGeom prst="rect">
@@ -11780,7 +12142,7 @@
           <a:p>
             <a:pPr algn="ctr"/>
             <a:r>
-              <a:rPr sz="2800" b="1" i="0">
+              <a:rPr sz="2800" b="1" i="0" dirty="0">
                 <a:solidFill>
                   <a:srgbClr val="6E6E73"/>
                 </a:solidFill>
@@ -11800,7 +12162,7 @@
 </file>
 
 <file path=ppt/slides/slide18.xml><?xml version="1.0" encoding="utf-8"?>
-<p:sld xmlns:a="http://schemas.openxmlformats.org/drawingml/2006/main" xmlns:p="http://schemas.openxmlformats.org/presentationml/2006/main" xmlns:r="http://schemas.openxmlformats.org/officeDocument/2006/relationships">
+<p:sld xmlns:a="http://schemas.openxmlformats.org/drawingml/2006/main" xmlns:r="http://schemas.openxmlformats.org/officeDocument/2006/relationships" xmlns:p="http://schemas.openxmlformats.org/presentationml/2006/main">
   <p:cSld>
     <p:bg>
       <p:bgPr>
@@ -11816,7 +12178,14 @@
         <p:cNvGrpSpPr/>
         <p:nvPr/>
       </p:nvGrpSpPr>
-      <p:grpSpPr/>
+      <p:grpSpPr>
+        <a:xfrm>
+          <a:off x="0" y="0"/>
+          <a:ext cx="0" cy="0"/>
+          <a:chOff x="0" y="0"/>
+          <a:chExt cx="0" cy="0"/>
+        </a:xfrm>
+      </p:grpSpPr>
       <p:sp>
         <p:nvSpPr>
           <p:cNvPr id="2" name="Rectangle 1"/>
@@ -11857,6 +12226,7 @@
           <a:lstStyle/>
           <a:p>
             <a:pPr algn="ctr"/>
+            <a:endParaRPr/>
           </a:p>
         </p:txBody>
       </p:sp>
@@ -11974,7 +12344,7 @@
 </file>
 
 <file path=ppt/slides/slide19.xml><?xml version="1.0" encoding="utf-8"?>
-<p:sld xmlns:a="http://schemas.openxmlformats.org/drawingml/2006/main" xmlns:p="http://schemas.openxmlformats.org/presentationml/2006/main" xmlns:r="http://schemas.openxmlformats.org/officeDocument/2006/relationships">
+<p:sld xmlns:a="http://schemas.openxmlformats.org/drawingml/2006/main" xmlns:r="http://schemas.openxmlformats.org/officeDocument/2006/relationships" xmlns:p="http://schemas.openxmlformats.org/presentationml/2006/main">
   <p:cSld>
     <p:bg>
       <p:bgPr>
@@ -11990,7 +12360,14 @@
         <p:cNvGrpSpPr/>
         <p:nvPr/>
       </p:nvGrpSpPr>
-      <p:grpSpPr/>
+      <p:grpSpPr>
+        <a:xfrm>
+          <a:off x="0" y="0"/>
+          <a:ext cx="0" cy="0"/>
+          <a:chOff x="0" y="0"/>
+          <a:chExt cx="0" cy="0"/>
+        </a:xfrm>
+      </p:grpSpPr>
       <p:sp>
         <p:nvSpPr>
           <p:cNvPr id="2" name="Rectangle 1"/>
@@ -12031,6 +12408,7 @@
           <a:lstStyle/>
           <a:p>
             <a:pPr algn="ctr"/>
+            <a:endParaRPr/>
           </a:p>
         </p:txBody>
       </p:sp>
@@ -12074,6 +12452,7 @@
           <a:lstStyle/>
           <a:p>
             <a:pPr algn="ctr"/>
+            <a:endParaRPr/>
           </a:p>
         </p:txBody>
       </p:sp>
@@ -12187,6 +12566,7 @@
           <a:lstStyle/>
           <a:p>
             <a:pPr algn="ctr"/>
+            <a:endParaRPr/>
           </a:p>
         </p:txBody>
       </p:sp>
@@ -12300,6 +12680,7 @@
           <a:lstStyle/>
           <a:p>
             <a:pPr algn="ctr"/>
+            <a:endParaRPr/>
           </a:p>
         </p:txBody>
       </p:sp>
@@ -12343,6 +12724,7 @@
           <a:lstStyle/>
           <a:p>
             <a:pPr algn="ctr"/>
+            <a:endParaRPr/>
           </a:p>
         </p:txBody>
       </p:sp>
@@ -12456,6 +12838,7 @@
           <a:lstStyle/>
           <a:p>
             <a:pPr algn="ctr"/>
+            <a:endParaRPr/>
           </a:p>
         </p:txBody>
       </p:sp>
@@ -12499,6 +12882,7 @@
           <a:lstStyle/>
           <a:p>
             <a:pPr algn="ctr"/>
+            <a:endParaRPr/>
           </a:p>
         </p:txBody>
       </p:sp>
@@ -12612,6 +12996,7 @@
           <a:lstStyle/>
           <a:p>
             <a:pPr algn="ctr"/>
+            <a:endParaRPr/>
           </a:p>
         </p:txBody>
       </p:sp>
@@ -12655,6 +13040,7 @@
           <a:lstStyle/>
           <a:p>
             <a:pPr algn="ctr"/>
+            <a:endParaRPr/>
           </a:p>
         </p:txBody>
       </p:sp>
@@ -12768,6 +13154,7 @@
           <a:lstStyle/>
           <a:p>
             <a:pPr algn="ctr"/>
+            <a:endParaRPr/>
           </a:p>
         </p:txBody>
       </p:sp>
@@ -12811,6 +13198,7 @@
           <a:lstStyle/>
           <a:p>
             <a:pPr algn="ctr"/>
+            <a:endParaRPr/>
           </a:p>
         </p:txBody>
       </p:sp>
@@ -12924,6 +13312,7 @@
           <a:lstStyle/>
           <a:p>
             <a:pPr algn="ctr"/>
+            <a:endParaRPr/>
           </a:p>
         </p:txBody>
       </p:sp>
@@ -12967,6 +13356,7 @@
           <a:lstStyle/>
           <a:p>
             <a:pPr algn="ctr"/>
+            <a:endParaRPr/>
           </a:p>
         </p:txBody>
       </p:sp>
@@ -13080,6 +13470,7 @@
           <a:lstStyle/>
           <a:p>
             <a:pPr algn="ctr"/>
+            <a:endParaRPr/>
           </a:p>
         </p:txBody>
       </p:sp>
@@ -13123,6 +13514,7 @@
           <a:lstStyle/>
           <a:p>
             <a:pPr algn="ctr"/>
+            <a:endParaRPr/>
           </a:p>
         </p:txBody>
       </p:sp>
@@ -13205,7 +13597,7 @@
 </file>
 
 <file path=ppt/slides/slide2.xml><?xml version="1.0" encoding="utf-8"?>
-<p:sld xmlns:a="http://schemas.openxmlformats.org/drawingml/2006/main" xmlns:p="http://schemas.openxmlformats.org/presentationml/2006/main" xmlns:r="http://schemas.openxmlformats.org/officeDocument/2006/relationships">
+<p:sld xmlns:a="http://schemas.openxmlformats.org/drawingml/2006/main" xmlns:r="http://schemas.openxmlformats.org/officeDocument/2006/relationships" xmlns:p="http://schemas.openxmlformats.org/presentationml/2006/main">
   <p:cSld>
     <p:bg>
       <p:bgPr>
@@ -13221,7 +13613,14 @@
         <p:cNvGrpSpPr/>
         <p:nvPr/>
       </p:nvGrpSpPr>
-      <p:grpSpPr/>
+      <p:grpSpPr>
+        <a:xfrm>
+          <a:off x="0" y="0"/>
+          <a:ext cx="0" cy="0"/>
+          <a:chOff x="0" y="0"/>
+          <a:chExt cx="0" cy="0"/>
+        </a:xfrm>
+      </p:grpSpPr>
       <p:sp>
         <p:nvSpPr>
           <p:cNvPr id="2" name="Rectangle 1"/>
@@ -13262,6 +13661,7 @@
           <a:lstStyle/>
           <a:p>
             <a:pPr algn="ctr"/>
+            <a:endParaRPr/>
           </a:p>
         </p:txBody>
       </p:sp>
@@ -13340,6 +13740,7 @@
           <a:lstStyle/>
           <a:p>
             <a:pPr algn="ctr"/>
+            <a:endParaRPr/>
           </a:p>
         </p:txBody>
       </p:sp>
@@ -13383,6 +13784,7 @@
           <a:lstStyle/>
           <a:p>
             <a:pPr algn="ctr"/>
+            <a:endParaRPr/>
           </a:p>
         </p:txBody>
       </p:sp>
@@ -13496,6 +13898,7 @@
           <a:lstStyle/>
           <a:p>
             <a:pPr algn="ctr"/>
+            <a:endParaRPr/>
           </a:p>
         </p:txBody>
       </p:sp>
@@ -13609,6 +14012,7 @@
           <a:lstStyle/>
           <a:p>
             <a:pPr algn="ctr"/>
+            <a:endParaRPr/>
           </a:p>
         </p:txBody>
       </p:sp>
@@ -13722,6 +14126,7 @@
           <a:lstStyle/>
           <a:p>
             <a:pPr algn="ctr"/>
+            <a:endParaRPr/>
           </a:p>
         </p:txBody>
       </p:sp>
@@ -13835,6 +14240,7 @@
           <a:lstStyle/>
           <a:p>
             <a:pPr algn="ctr"/>
+            <a:endParaRPr/>
           </a:p>
         </p:txBody>
       </p:sp>
@@ -13948,6 +14354,7 @@
           <a:lstStyle/>
           <a:p>
             <a:pPr algn="ctr"/>
+            <a:endParaRPr/>
           </a:p>
         </p:txBody>
       </p:sp>
@@ -14061,6 +14468,7 @@
           <a:lstStyle/>
           <a:p>
             <a:pPr algn="ctr"/>
+            <a:endParaRPr/>
           </a:p>
         </p:txBody>
       </p:sp>
@@ -14143,7 +14551,7 @@
 </file>
 
 <file path=ppt/slides/slide20.xml><?xml version="1.0" encoding="utf-8"?>
-<p:sld xmlns:a="http://schemas.openxmlformats.org/drawingml/2006/main" xmlns:p="http://schemas.openxmlformats.org/presentationml/2006/main" xmlns:r="http://schemas.openxmlformats.org/officeDocument/2006/relationships">
+<p:sld xmlns:a="http://schemas.openxmlformats.org/drawingml/2006/main" xmlns:r="http://schemas.openxmlformats.org/officeDocument/2006/relationships" xmlns:p="http://schemas.openxmlformats.org/presentationml/2006/main">
   <p:cSld>
     <p:bg>
       <p:bgPr>
@@ -14159,7 +14567,14 @@
         <p:cNvGrpSpPr/>
         <p:nvPr/>
       </p:nvGrpSpPr>
-      <p:grpSpPr/>
+      <p:grpSpPr>
+        <a:xfrm>
+          <a:off x="0" y="0"/>
+          <a:ext cx="0" cy="0"/>
+          <a:chOff x="0" y="0"/>
+          <a:chExt cx="0" cy="0"/>
+        </a:xfrm>
+      </p:grpSpPr>
       <p:sp>
         <p:nvSpPr>
           <p:cNvPr id="2" name="Rectangle 1"/>
@@ -14200,6 +14615,7 @@
           <a:lstStyle/>
           <a:p>
             <a:pPr algn="ctr"/>
+            <a:endParaRPr/>
           </a:p>
         </p:txBody>
       </p:sp>
@@ -14243,6 +14659,7 @@
           <a:lstStyle/>
           <a:p>
             <a:pPr algn="ctr"/>
+            <a:endParaRPr/>
           </a:p>
         </p:txBody>
       </p:sp>
@@ -14356,6 +14773,7 @@
           <a:lstStyle/>
           <a:p>
             <a:pPr algn="ctr"/>
+            <a:endParaRPr/>
           </a:p>
         </p:txBody>
       </p:sp>
@@ -14378,11 +14796,41 @@
                 <a:tableStyleId>{5C22544A-7EE6-4342-B048-85BDC9FD1C3A}</a:tableStyleId>
               </a:tblPr>
               <a:tblGrid>
-                <a:gridCol w="2286000"/>
-                <a:gridCol w="2286000"/>
-                <a:gridCol w="2286000"/>
-                <a:gridCol w="2286000"/>
-                <a:gridCol w="2286000"/>
+                <a:gridCol w="2286000">
+                  <a:extLst>
+                    <a:ext uri="{9D8B030D-6E8A-4147-A177-3AD203B41FA5}">
+                      <a16:colId xmlns:a16="http://schemas.microsoft.com/office/drawing/2014/main" val="20000"/>
+                    </a:ext>
+                  </a:extLst>
+                </a:gridCol>
+                <a:gridCol w="2286000">
+                  <a:extLst>
+                    <a:ext uri="{9D8B030D-6E8A-4147-A177-3AD203B41FA5}">
+                      <a16:colId xmlns:a16="http://schemas.microsoft.com/office/drawing/2014/main" val="20001"/>
+                    </a:ext>
+                  </a:extLst>
+                </a:gridCol>
+                <a:gridCol w="2286000">
+                  <a:extLst>
+                    <a:ext uri="{9D8B030D-6E8A-4147-A177-3AD203B41FA5}">
+                      <a16:colId xmlns:a16="http://schemas.microsoft.com/office/drawing/2014/main" val="20002"/>
+                    </a:ext>
+                  </a:extLst>
+                </a:gridCol>
+                <a:gridCol w="2286000">
+                  <a:extLst>
+                    <a:ext uri="{9D8B030D-6E8A-4147-A177-3AD203B41FA5}">
+                      <a16:colId xmlns:a16="http://schemas.microsoft.com/office/drawing/2014/main" val="20003"/>
+                    </a:ext>
+                  </a:extLst>
+                </a:gridCol>
+                <a:gridCol w="2286000">
+                  <a:extLst>
+                    <a:ext uri="{9D8B030D-6E8A-4147-A177-3AD203B41FA5}">
+                      <a16:colId xmlns:a16="http://schemas.microsoft.com/office/drawing/2014/main" val="20004"/>
+                    </a:ext>
+                  </a:extLst>
+                </a:gridCol>
               </a:tblGrid>
               <a:tr h="457200">
                 <a:tc>
@@ -14500,6 +14948,11 @@
                     </a:solidFill>
                   </a:tcPr>
                 </a:tc>
+                <a:extLst>
+                  <a:ext uri="{0D108BD9-81ED-4DB2-BD59-A6C34878D82A}">
+                    <a16:rowId xmlns:a16="http://schemas.microsoft.com/office/drawing/2014/main" val="10000"/>
+                  </a:ext>
+                </a:extLst>
               </a:tr>
               <a:tr h="457200">
                 <a:tc>
@@ -14617,6 +15070,11 @@
                     </a:solidFill>
                   </a:tcPr>
                 </a:tc>
+                <a:extLst>
+                  <a:ext uri="{0D108BD9-81ED-4DB2-BD59-A6C34878D82A}">
+                    <a16:rowId xmlns:a16="http://schemas.microsoft.com/office/drawing/2014/main" val="10001"/>
+                  </a:ext>
+                </a:extLst>
               </a:tr>
               <a:tr h="457200">
                 <a:tc>
@@ -14734,6 +15192,11 @@
                     </a:solidFill>
                   </a:tcPr>
                 </a:tc>
+                <a:extLst>
+                  <a:ext uri="{0D108BD9-81ED-4DB2-BD59-A6C34878D82A}">
+                    <a16:rowId xmlns:a16="http://schemas.microsoft.com/office/drawing/2014/main" val="10002"/>
+                  </a:ext>
+                </a:extLst>
               </a:tr>
               <a:tr h="457200">
                 <a:tc>
@@ -14851,6 +15314,11 @@
                     </a:solidFill>
                   </a:tcPr>
                 </a:tc>
+                <a:extLst>
+                  <a:ext uri="{0D108BD9-81ED-4DB2-BD59-A6C34878D82A}">
+                    <a16:rowId xmlns:a16="http://schemas.microsoft.com/office/drawing/2014/main" val="10003"/>
+                  </a:ext>
+                </a:extLst>
               </a:tr>
               <a:tr h="457200">
                 <a:tc>
@@ -14968,6 +15436,11 @@
                     </a:solidFill>
                   </a:tcPr>
                 </a:tc>
+                <a:extLst>
+                  <a:ext uri="{0D108BD9-81ED-4DB2-BD59-A6C34878D82A}">
+                    <a16:rowId xmlns:a16="http://schemas.microsoft.com/office/drawing/2014/main" val="10004"/>
+                  </a:ext>
+                </a:extLst>
               </a:tr>
               <a:tr h="457200">
                 <a:tc>
@@ -15085,6 +15558,11 @@
                     </a:solidFill>
                   </a:tcPr>
                 </a:tc>
+                <a:extLst>
+                  <a:ext uri="{0D108BD9-81ED-4DB2-BD59-A6C34878D82A}">
+                    <a16:rowId xmlns:a16="http://schemas.microsoft.com/office/drawing/2014/main" val="10005"/>
+                  </a:ext>
+                </a:extLst>
               </a:tr>
               <a:tr h="457200">
                 <a:tc>
@@ -15202,6 +15680,11 @@
                     </a:solidFill>
                   </a:tcPr>
                 </a:tc>
+                <a:extLst>
+                  <a:ext uri="{0D108BD9-81ED-4DB2-BD59-A6C34878D82A}">
+                    <a16:rowId xmlns:a16="http://schemas.microsoft.com/office/drawing/2014/main" val="10006"/>
+                  </a:ext>
+                </a:extLst>
               </a:tr>
               <a:tr h="457200">
                 <a:tc>
@@ -15319,6 +15802,11 @@
                     </a:solidFill>
                   </a:tcPr>
                 </a:tc>
+                <a:extLst>
+                  <a:ext uri="{0D108BD9-81ED-4DB2-BD59-A6C34878D82A}">
+                    <a16:rowId xmlns:a16="http://schemas.microsoft.com/office/drawing/2014/main" val="10007"/>
+                  </a:ext>
+                </a:extLst>
               </a:tr>
             </a:tbl>
           </a:graphicData>
@@ -15399,6 +15887,7 @@
           <a:lstStyle/>
           <a:p>
             <a:pPr algn="ctr"/>
+            <a:endParaRPr/>
           </a:p>
         </p:txBody>
       </p:sp>
@@ -15477,6 +15966,7 @@
           <a:lstStyle/>
           <a:p>
             <a:pPr algn="ctr"/>
+            <a:endParaRPr/>
           </a:p>
         </p:txBody>
       </p:sp>
@@ -15555,6 +16045,7 @@
           <a:lstStyle/>
           <a:p>
             <a:pPr algn="ctr"/>
+            <a:endParaRPr/>
           </a:p>
         </p:txBody>
       </p:sp>
@@ -15602,7 +16093,7 @@
 </file>
 
 <file path=ppt/slides/slide21.xml><?xml version="1.0" encoding="utf-8"?>
-<p:sld xmlns:a="http://schemas.openxmlformats.org/drawingml/2006/main" xmlns:p="http://schemas.openxmlformats.org/presentationml/2006/main" xmlns:r="http://schemas.openxmlformats.org/officeDocument/2006/relationships">
+<p:sld xmlns:a="http://schemas.openxmlformats.org/drawingml/2006/main" xmlns:r="http://schemas.openxmlformats.org/officeDocument/2006/relationships" xmlns:p="http://schemas.openxmlformats.org/presentationml/2006/main">
   <p:cSld>
     <p:bg>
       <p:bgPr>
@@ -15618,7 +16109,14 @@
         <p:cNvGrpSpPr/>
         <p:nvPr/>
       </p:nvGrpSpPr>
-      <p:grpSpPr/>
+      <p:grpSpPr>
+        <a:xfrm>
+          <a:off x="0" y="0"/>
+          <a:ext cx="0" cy="0"/>
+          <a:chOff x="0" y="0"/>
+          <a:chExt cx="0" cy="0"/>
+        </a:xfrm>
+      </p:grpSpPr>
       <p:sp>
         <p:nvSpPr>
           <p:cNvPr id="2" name="Rectangle 1"/>
@@ -15659,6 +16157,7 @@
           <a:lstStyle/>
           <a:p>
             <a:pPr algn="ctr"/>
+            <a:endParaRPr/>
           </a:p>
         </p:txBody>
       </p:sp>
@@ -15776,7 +16275,7 @@
 </file>
 
 <file path=ppt/slides/slide22.xml><?xml version="1.0" encoding="utf-8"?>
-<p:sld xmlns:a="http://schemas.openxmlformats.org/drawingml/2006/main" xmlns:p="http://schemas.openxmlformats.org/presentationml/2006/main" xmlns:r="http://schemas.openxmlformats.org/officeDocument/2006/relationships">
+<p:sld xmlns:a="http://schemas.openxmlformats.org/drawingml/2006/main" xmlns:r="http://schemas.openxmlformats.org/officeDocument/2006/relationships" xmlns:p="http://schemas.openxmlformats.org/presentationml/2006/main">
   <p:cSld>
     <p:bg>
       <p:bgPr>
@@ -15792,7 +16291,14 @@
         <p:cNvGrpSpPr/>
         <p:nvPr/>
       </p:nvGrpSpPr>
-      <p:grpSpPr/>
+      <p:grpSpPr>
+        <a:xfrm>
+          <a:off x="0" y="0"/>
+          <a:ext cx="0" cy="0"/>
+          <a:chOff x="0" y="0"/>
+          <a:chExt cx="0" cy="0"/>
+        </a:xfrm>
+      </p:grpSpPr>
       <p:sp>
         <p:nvSpPr>
           <p:cNvPr id="2" name="Rectangle 1"/>
@@ -15833,6 +16339,7 @@
           <a:lstStyle/>
           <a:p>
             <a:pPr algn="ctr"/>
+            <a:endParaRPr/>
           </a:p>
         </p:txBody>
       </p:sp>
@@ -15876,6 +16383,7 @@
           <a:lstStyle/>
           <a:p>
             <a:pPr algn="ctr"/>
+            <a:endParaRPr/>
           </a:p>
         </p:txBody>
       </p:sp>
@@ -15989,6 +16497,7 @@
           <a:lstStyle/>
           <a:p>
             <a:pPr algn="ctr"/>
+            <a:endParaRPr/>
           </a:p>
         </p:txBody>
       </p:sp>
@@ -16032,6 +16541,7 @@
           <a:lstStyle/>
           <a:p>
             <a:pPr algn="ctr"/>
+            <a:endParaRPr/>
           </a:p>
         </p:txBody>
       </p:sp>
@@ -16075,6 +16585,7 @@
           <a:lstStyle/>
           <a:p>
             <a:pPr algn="ctr"/>
+            <a:endParaRPr/>
           </a:p>
         </p:txBody>
       </p:sp>
@@ -16188,6 +16699,7 @@
           <a:lstStyle/>
           <a:p>
             <a:pPr algn="ctr"/>
+            <a:endParaRPr/>
           </a:p>
         </p:txBody>
       </p:sp>
@@ -16231,6 +16743,7 @@
           <a:lstStyle/>
           <a:p>
             <a:pPr algn="ctr"/>
+            <a:endParaRPr/>
           </a:p>
         </p:txBody>
       </p:sp>
@@ -16344,6 +16857,7 @@
           <a:lstStyle/>
           <a:p>
             <a:pPr algn="ctr"/>
+            <a:endParaRPr/>
           </a:p>
         </p:txBody>
       </p:sp>
@@ -16387,6 +16901,7 @@
           <a:lstStyle/>
           <a:p>
             <a:pPr algn="ctr"/>
+            <a:endParaRPr/>
           </a:p>
         </p:txBody>
       </p:sp>
@@ -16479,13 +16994,55 @@
                 <a:tableStyleId>{5C22544A-7EE6-4342-B048-85BDC9FD1C3A}</a:tableStyleId>
               </a:tblPr>
               <a:tblGrid>
-                <a:gridCol w="1658982"/>
-                <a:gridCol w="1658982"/>
-                <a:gridCol w="1658982"/>
-                <a:gridCol w="1658982"/>
-                <a:gridCol w="1658982"/>
-                <a:gridCol w="1658982"/>
-                <a:gridCol w="1658988"/>
+                <a:gridCol w="1658982">
+                  <a:extLst>
+                    <a:ext uri="{9D8B030D-6E8A-4147-A177-3AD203B41FA5}">
+                      <a16:colId xmlns:a16="http://schemas.microsoft.com/office/drawing/2014/main" val="20000"/>
+                    </a:ext>
+                  </a:extLst>
+                </a:gridCol>
+                <a:gridCol w="1658982">
+                  <a:extLst>
+                    <a:ext uri="{9D8B030D-6E8A-4147-A177-3AD203B41FA5}">
+                      <a16:colId xmlns:a16="http://schemas.microsoft.com/office/drawing/2014/main" val="20001"/>
+                    </a:ext>
+                  </a:extLst>
+                </a:gridCol>
+                <a:gridCol w="1658982">
+                  <a:extLst>
+                    <a:ext uri="{9D8B030D-6E8A-4147-A177-3AD203B41FA5}">
+                      <a16:colId xmlns:a16="http://schemas.microsoft.com/office/drawing/2014/main" val="20002"/>
+                    </a:ext>
+                  </a:extLst>
+                </a:gridCol>
+                <a:gridCol w="1658982">
+                  <a:extLst>
+                    <a:ext uri="{9D8B030D-6E8A-4147-A177-3AD203B41FA5}">
+                      <a16:colId xmlns:a16="http://schemas.microsoft.com/office/drawing/2014/main" val="20003"/>
+                    </a:ext>
+                  </a:extLst>
+                </a:gridCol>
+                <a:gridCol w="1658982">
+                  <a:extLst>
+                    <a:ext uri="{9D8B030D-6E8A-4147-A177-3AD203B41FA5}">
+                      <a16:colId xmlns:a16="http://schemas.microsoft.com/office/drawing/2014/main" val="20004"/>
+                    </a:ext>
+                  </a:extLst>
+                </a:gridCol>
+                <a:gridCol w="1658982">
+                  <a:extLst>
+                    <a:ext uri="{9D8B030D-6E8A-4147-A177-3AD203B41FA5}">
+                      <a16:colId xmlns:a16="http://schemas.microsoft.com/office/drawing/2014/main" val="20005"/>
+                    </a:ext>
+                  </a:extLst>
+                </a:gridCol>
+                <a:gridCol w="1658988">
+                  <a:extLst>
+                    <a:ext uri="{9D8B030D-6E8A-4147-A177-3AD203B41FA5}">
+                      <a16:colId xmlns:a16="http://schemas.microsoft.com/office/drawing/2014/main" val="20006"/>
+                    </a:ext>
+                  </a:extLst>
+                </a:gridCol>
               </a:tblGrid>
               <a:tr h="434340">
                 <a:tc>
@@ -16649,6 +17206,11 @@
                     </a:solidFill>
                   </a:tcPr>
                 </a:tc>
+                <a:extLst>
+                  <a:ext uri="{0D108BD9-81ED-4DB2-BD59-A6C34878D82A}">
+                    <a16:rowId xmlns:a16="http://schemas.microsoft.com/office/drawing/2014/main" val="10000"/>
+                  </a:ext>
+                </a:extLst>
               </a:tr>
               <a:tr h="434340">
                 <a:tc>
@@ -16812,6 +17374,11 @@
                     </a:solidFill>
                   </a:tcPr>
                 </a:tc>
+                <a:extLst>
+                  <a:ext uri="{0D108BD9-81ED-4DB2-BD59-A6C34878D82A}">
+                    <a16:rowId xmlns:a16="http://schemas.microsoft.com/office/drawing/2014/main" val="10001"/>
+                  </a:ext>
+                </a:extLst>
               </a:tr>
               <a:tr h="434340">
                 <a:tc>
@@ -16975,6 +17542,11 @@
                     </a:solidFill>
                   </a:tcPr>
                 </a:tc>
+                <a:extLst>
+                  <a:ext uri="{0D108BD9-81ED-4DB2-BD59-A6C34878D82A}">
+                    <a16:rowId xmlns:a16="http://schemas.microsoft.com/office/drawing/2014/main" val="10002"/>
+                  </a:ext>
+                </a:extLst>
               </a:tr>
               <a:tr h="434340">
                 <a:tc>
@@ -17138,6 +17710,11 @@
                     </a:solidFill>
                   </a:tcPr>
                 </a:tc>
+                <a:extLst>
+                  <a:ext uri="{0D108BD9-81ED-4DB2-BD59-A6C34878D82A}">
+                    <a16:rowId xmlns:a16="http://schemas.microsoft.com/office/drawing/2014/main" val="10003"/>
+                  </a:ext>
+                </a:extLst>
               </a:tr>
               <a:tr h="434340">
                 <a:tc>
@@ -17301,6 +17878,11 @@
                     </a:solidFill>
                   </a:tcPr>
                 </a:tc>
+                <a:extLst>
+                  <a:ext uri="{0D108BD9-81ED-4DB2-BD59-A6C34878D82A}">
+                    <a16:rowId xmlns:a16="http://schemas.microsoft.com/office/drawing/2014/main" val="10004"/>
+                  </a:ext>
+                </a:extLst>
               </a:tr>
               <a:tr h="434340">
                 <a:tc>
@@ -17464,6 +18046,11 @@
                     </a:solidFill>
                   </a:tcPr>
                 </a:tc>
+                <a:extLst>
+                  <a:ext uri="{0D108BD9-81ED-4DB2-BD59-A6C34878D82A}">
+                    <a16:rowId xmlns:a16="http://schemas.microsoft.com/office/drawing/2014/main" val="10005"/>
+                  </a:ext>
+                </a:extLst>
               </a:tr>
               <a:tr h="434340">
                 <a:tc>
@@ -17627,6 +18214,11 @@
                     </a:solidFill>
                   </a:tcPr>
                 </a:tc>
+                <a:extLst>
+                  <a:ext uri="{0D108BD9-81ED-4DB2-BD59-A6C34878D82A}">
+                    <a16:rowId xmlns:a16="http://schemas.microsoft.com/office/drawing/2014/main" val="10006"/>
+                  </a:ext>
+                </a:extLst>
               </a:tr>
               <a:tr h="434340">
                 <a:tc>
@@ -17790,6 +18382,11 @@
                     </a:solidFill>
                   </a:tcPr>
                 </a:tc>
+                <a:extLst>
+                  <a:ext uri="{0D108BD9-81ED-4DB2-BD59-A6C34878D82A}">
+                    <a16:rowId xmlns:a16="http://schemas.microsoft.com/office/drawing/2014/main" val="10007"/>
+                  </a:ext>
+                </a:extLst>
               </a:tr>
             </a:tbl>
           </a:graphicData>
@@ -17804,7 +18401,7 @@
 </file>
 
 <file path=ppt/slides/slide23.xml><?xml version="1.0" encoding="utf-8"?>
-<p:sld xmlns:a="http://schemas.openxmlformats.org/drawingml/2006/main" xmlns:p="http://schemas.openxmlformats.org/presentationml/2006/main" xmlns:r="http://schemas.openxmlformats.org/officeDocument/2006/relationships">
+<p:sld xmlns:a="http://schemas.openxmlformats.org/drawingml/2006/main" xmlns:r="http://schemas.openxmlformats.org/officeDocument/2006/relationships" xmlns:p="http://schemas.openxmlformats.org/presentationml/2006/main">
   <p:cSld>
     <p:bg>
       <p:bgPr>
@@ -17820,7 +18417,14 @@
         <p:cNvGrpSpPr/>
         <p:nvPr/>
       </p:nvGrpSpPr>
-      <p:grpSpPr/>
+      <p:grpSpPr>
+        <a:xfrm>
+          <a:off x="0" y="0"/>
+          <a:ext cx="0" cy="0"/>
+          <a:chOff x="0" y="0"/>
+          <a:chExt cx="0" cy="0"/>
+        </a:xfrm>
+      </p:grpSpPr>
       <p:sp>
         <p:nvSpPr>
           <p:cNvPr id="2" name="Rectangle 1"/>
@@ -17861,6 +18465,7 @@
           <a:lstStyle/>
           <a:p>
             <a:pPr algn="ctr"/>
+            <a:endParaRPr/>
           </a:p>
         </p:txBody>
       </p:sp>
@@ -17904,6 +18509,7 @@
           <a:lstStyle/>
           <a:p>
             <a:pPr algn="ctr"/>
+            <a:endParaRPr/>
           </a:p>
         </p:txBody>
       </p:sp>
@@ -18017,6 +18623,7 @@
           <a:lstStyle/>
           <a:p>
             <a:pPr algn="ctr"/>
+            <a:endParaRPr/>
           </a:p>
         </p:txBody>
       </p:sp>
@@ -18097,6 +18704,7 @@
           <a:lstStyle/>
           <a:p>
             <a:pPr algn="ctr"/>
+            <a:endParaRPr/>
           </a:p>
         </p:txBody>
       </p:sp>
@@ -18175,6 +18783,7 @@
           <a:lstStyle/>
           <a:p>
             <a:pPr algn="ctr"/>
+            <a:endParaRPr/>
           </a:p>
         </p:txBody>
       </p:sp>
@@ -18288,6 +18897,7 @@
           <a:lstStyle/>
           <a:p>
             <a:pPr algn="ctr"/>
+            <a:endParaRPr/>
           </a:p>
         </p:txBody>
       </p:sp>
@@ -18368,6 +18978,7 @@
           <a:lstStyle/>
           <a:p>
             <a:pPr algn="ctr"/>
+            <a:endParaRPr/>
           </a:p>
         </p:txBody>
       </p:sp>
@@ -18446,6 +19057,7 @@
           <a:lstStyle/>
           <a:p>
             <a:pPr algn="ctr"/>
+            <a:endParaRPr/>
           </a:p>
         </p:txBody>
       </p:sp>
@@ -18559,6 +19171,7 @@
           <a:lstStyle/>
           <a:p>
             <a:pPr algn="ctr"/>
+            <a:endParaRPr/>
           </a:p>
         </p:txBody>
       </p:sp>
@@ -18639,6 +19252,7 @@
           <a:lstStyle/>
           <a:p>
             <a:pPr algn="ctr"/>
+            <a:endParaRPr/>
           </a:p>
         </p:txBody>
       </p:sp>
@@ -18717,6 +19331,7 @@
           <a:lstStyle/>
           <a:p>
             <a:pPr algn="ctr"/>
+            <a:endParaRPr/>
           </a:p>
         </p:txBody>
       </p:sp>
@@ -18830,6 +19445,7 @@
           <a:lstStyle/>
           <a:p>
             <a:pPr algn="ctr"/>
+            <a:endParaRPr/>
           </a:p>
         </p:txBody>
       </p:sp>
@@ -18943,6 +19559,7 @@
           <a:lstStyle/>
           <a:p>
             <a:pPr algn="ctr"/>
+            <a:endParaRPr/>
           </a:p>
         </p:txBody>
       </p:sp>
@@ -18986,6 +19603,7 @@
           <a:lstStyle/>
           <a:p>
             <a:pPr algn="ctr"/>
+            <a:endParaRPr/>
           </a:p>
         </p:txBody>
       </p:sp>
@@ -19100,6 +19718,7 @@
           <a:lstStyle/>
           <a:p>
             <a:pPr algn="ctr"/>
+            <a:endParaRPr/>
           </a:p>
         </p:txBody>
       </p:sp>
@@ -19178,6 +19797,7 @@
           <a:lstStyle/>
           <a:p>
             <a:pPr algn="ctr"/>
+            <a:endParaRPr/>
           </a:p>
         </p:txBody>
       </p:sp>
@@ -19221,6 +19841,7 @@
           <a:lstStyle/>
           <a:p>
             <a:pPr algn="ctr"/>
+            <a:endParaRPr/>
           </a:p>
         </p:txBody>
       </p:sp>
@@ -19335,6 +19956,7 @@
           <a:lstStyle/>
           <a:p>
             <a:pPr algn="ctr"/>
+            <a:endParaRPr/>
           </a:p>
         </p:txBody>
       </p:sp>
@@ -19382,7 +20004,7 @@
 </file>
 
 <file path=ppt/slides/slide24.xml><?xml version="1.0" encoding="utf-8"?>
-<p:sld xmlns:a="http://schemas.openxmlformats.org/drawingml/2006/main" xmlns:p="http://schemas.openxmlformats.org/presentationml/2006/main" xmlns:r="http://schemas.openxmlformats.org/officeDocument/2006/relationships">
+<p:sld xmlns:a="http://schemas.openxmlformats.org/drawingml/2006/main" xmlns:r="http://schemas.openxmlformats.org/officeDocument/2006/relationships" xmlns:p="http://schemas.openxmlformats.org/presentationml/2006/main">
   <p:cSld>
     <p:bg>
       <p:bgPr>
@@ -19398,7 +20020,14 @@
         <p:cNvGrpSpPr/>
         <p:nvPr/>
       </p:nvGrpSpPr>
-      <p:grpSpPr/>
+      <p:grpSpPr>
+        <a:xfrm>
+          <a:off x="0" y="0"/>
+          <a:ext cx="0" cy="0"/>
+          <a:chOff x="0" y="0"/>
+          <a:chExt cx="0" cy="0"/>
+        </a:xfrm>
+      </p:grpSpPr>
       <p:sp>
         <p:nvSpPr>
           <p:cNvPr id="2" name="Rectangle 1"/>
@@ -19439,6 +20068,7 @@
           <a:lstStyle/>
           <a:p>
             <a:pPr algn="ctr"/>
+            <a:endParaRPr/>
           </a:p>
         </p:txBody>
       </p:sp>
@@ -19556,7 +20186,7 @@
 </file>
 
 <file path=ppt/slides/slide25.xml><?xml version="1.0" encoding="utf-8"?>
-<p:sld xmlns:a="http://schemas.openxmlformats.org/drawingml/2006/main" xmlns:p="http://schemas.openxmlformats.org/presentationml/2006/main" xmlns:r="http://schemas.openxmlformats.org/officeDocument/2006/relationships">
+<p:sld xmlns:a="http://schemas.openxmlformats.org/drawingml/2006/main" xmlns:r="http://schemas.openxmlformats.org/officeDocument/2006/relationships" xmlns:p="http://schemas.openxmlformats.org/presentationml/2006/main">
   <p:cSld>
     <p:bg>
       <p:bgPr>
@@ -19572,7 +20202,14 @@
         <p:cNvGrpSpPr/>
         <p:nvPr/>
       </p:nvGrpSpPr>
-      <p:grpSpPr/>
+      <p:grpSpPr>
+        <a:xfrm>
+          <a:off x="0" y="0"/>
+          <a:ext cx="0" cy="0"/>
+          <a:chOff x="0" y="0"/>
+          <a:chExt cx="0" cy="0"/>
+        </a:xfrm>
+      </p:grpSpPr>
       <p:sp>
         <p:nvSpPr>
           <p:cNvPr id="2" name="Rectangle 1"/>
@@ -19613,6 +20250,7 @@
           <a:lstStyle/>
           <a:p>
             <a:pPr algn="ctr"/>
+            <a:endParaRPr/>
           </a:p>
         </p:txBody>
       </p:sp>
@@ -19656,6 +20294,7 @@
           <a:lstStyle/>
           <a:p>
             <a:pPr algn="ctr"/>
+            <a:endParaRPr/>
           </a:p>
         </p:txBody>
       </p:sp>
@@ -19769,6 +20408,7 @@
           <a:lstStyle/>
           <a:p>
             <a:pPr algn="ctr"/>
+            <a:endParaRPr/>
           </a:p>
         </p:txBody>
       </p:sp>
@@ -19812,6 +20452,7 @@
           <a:lstStyle/>
           <a:p>
             <a:pPr algn="ctr"/>
+            <a:endParaRPr/>
           </a:p>
         </p:txBody>
       </p:sp>
@@ -19960,6 +20601,7 @@
           <a:lstStyle/>
           <a:p>
             <a:pPr algn="ctr"/>
+            <a:endParaRPr/>
           </a:p>
         </p:txBody>
       </p:sp>
@@ -20108,6 +20750,7 @@
           <a:lstStyle/>
           <a:p>
             <a:pPr algn="ctr"/>
+            <a:endParaRPr/>
           </a:p>
         </p:txBody>
       </p:sp>
@@ -20256,6 +20899,7 @@
           <a:lstStyle/>
           <a:p>
             <a:pPr algn="ctr"/>
+            <a:endParaRPr/>
           </a:p>
         </p:txBody>
       </p:sp>
@@ -20404,6 +21048,7 @@
           <a:lstStyle/>
           <a:p>
             <a:pPr algn="ctr"/>
+            <a:endParaRPr/>
           </a:p>
         </p:txBody>
       </p:sp>
@@ -20552,6 +21197,7 @@
           <a:lstStyle/>
           <a:p>
             <a:pPr algn="ctr"/>
+            <a:endParaRPr/>
           </a:p>
         </p:txBody>
       </p:sp>
@@ -20669,7 +21315,7 @@
 </file>
 
 <file path=ppt/slides/slide26.xml><?xml version="1.0" encoding="utf-8"?>
-<p:sld xmlns:a="http://schemas.openxmlformats.org/drawingml/2006/main" xmlns:p="http://schemas.openxmlformats.org/presentationml/2006/main" xmlns:r="http://schemas.openxmlformats.org/officeDocument/2006/relationships">
+<p:sld xmlns:a="http://schemas.openxmlformats.org/drawingml/2006/main" xmlns:r="http://schemas.openxmlformats.org/officeDocument/2006/relationships" xmlns:p="http://schemas.openxmlformats.org/presentationml/2006/main">
   <p:cSld>
     <p:bg>
       <p:bgPr>
@@ -20685,7 +21331,14 @@
         <p:cNvGrpSpPr/>
         <p:nvPr/>
       </p:nvGrpSpPr>
-      <p:grpSpPr/>
+      <p:grpSpPr>
+        <a:xfrm>
+          <a:off x="0" y="0"/>
+          <a:ext cx="0" cy="0"/>
+          <a:chOff x="0" y="0"/>
+          <a:chExt cx="0" cy="0"/>
+        </a:xfrm>
+      </p:grpSpPr>
       <p:sp>
         <p:nvSpPr>
           <p:cNvPr id="2" name="Rectangle 1"/>
@@ -20726,6 +21379,7 @@
           <a:lstStyle/>
           <a:p>
             <a:pPr algn="ctr"/>
+            <a:endParaRPr/>
           </a:p>
         </p:txBody>
       </p:sp>
@@ -20769,6 +21423,7 @@
           <a:lstStyle/>
           <a:p>
             <a:pPr algn="ctr"/>
+            <a:endParaRPr/>
           </a:p>
         </p:txBody>
       </p:sp>
@@ -20882,6 +21537,7 @@
           <a:lstStyle/>
           <a:p>
             <a:pPr algn="ctr"/>
+            <a:endParaRPr/>
           </a:p>
         </p:txBody>
       </p:sp>
@@ -20960,6 +21616,7 @@
           <a:lstStyle/>
           <a:p>
             <a:pPr algn="ctr"/>
+            <a:endParaRPr/>
           </a:p>
         </p:txBody>
       </p:sp>
@@ -21003,6 +21660,7 @@
           <a:lstStyle/>
           <a:p>
             <a:pPr algn="ctr"/>
+            <a:endParaRPr/>
           </a:p>
         </p:txBody>
       </p:sp>
@@ -21116,6 +21774,7 @@
           <a:lstStyle/>
           <a:p>
             <a:pPr algn="ctr"/>
+            <a:endParaRPr/>
           </a:p>
         </p:txBody>
       </p:sp>
@@ -21159,6 +21818,7 @@
           <a:lstStyle/>
           <a:p>
             <a:pPr algn="ctr"/>
+            <a:endParaRPr/>
           </a:p>
         </p:txBody>
       </p:sp>
@@ -21272,6 +21932,7 @@
           <a:lstStyle/>
           <a:p>
             <a:pPr algn="ctr"/>
+            <a:endParaRPr/>
           </a:p>
         </p:txBody>
       </p:sp>
@@ -21315,6 +21976,7 @@
           <a:lstStyle/>
           <a:p>
             <a:pPr algn="ctr"/>
+            <a:endParaRPr/>
           </a:p>
         </p:txBody>
       </p:sp>
@@ -21428,6 +22090,7 @@
           <a:lstStyle/>
           <a:p>
             <a:pPr algn="ctr"/>
+            <a:endParaRPr/>
           </a:p>
         </p:txBody>
       </p:sp>
@@ -21471,6 +22134,7 @@
           <a:lstStyle/>
           <a:p>
             <a:pPr algn="ctr"/>
+            <a:endParaRPr/>
           </a:p>
         </p:txBody>
       </p:sp>
@@ -21723,7 +22387,7 @@
 </file>
 
 <file path=ppt/slides/slide27.xml><?xml version="1.0" encoding="utf-8"?>
-<p:sld xmlns:a="http://schemas.openxmlformats.org/drawingml/2006/main" xmlns:p="http://schemas.openxmlformats.org/presentationml/2006/main" xmlns:r="http://schemas.openxmlformats.org/officeDocument/2006/relationships">
+<p:sld xmlns:a="http://schemas.openxmlformats.org/drawingml/2006/main" xmlns:r="http://schemas.openxmlformats.org/officeDocument/2006/relationships" xmlns:p="http://schemas.openxmlformats.org/presentationml/2006/main">
   <p:cSld>
     <p:bg>
       <p:bgPr>
@@ -21739,7 +22403,14 @@
         <p:cNvGrpSpPr/>
         <p:nvPr/>
       </p:nvGrpSpPr>
-      <p:grpSpPr/>
+      <p:grpSpPr>
+        <a:xfrm>
+          <a:off x="0" y="0"/>
+          <a:ext cx="0" cy="0"/>
+          <a:chOff x="0" y="0"/>
+          <a:chExt cx="0" cy="0"/>
+        </a:xfrm>
+      </p:grpSpPr>
       <p:sp>
         <p:nvSpPr>
           <p:cNvPr id="2" name="Rectangle 1"/>
@@ -21780,6 +22451,7 @@
           <a:lstStyle/>
           <a:p>
             <a:pPr algn="ctr"/>
+            <a:endParaRPr/>
           </a:p>
         </p:txBody>
       </p:sp>
@@ -21893,6 +22565,7 @@
           <a:lstStyle/>
           <a:p>
             <a:pPr algn="ctr"/>
+            <a:endParaRPr/>
           </a:p>
         </p:txBody>
       </p:sp>
@@ -21971,6 +22644,7 @@
           <a:lstStyle/>
           <a:p>
             <a:pPr algn="ctr"/>
+            <a:endParaRPr/>
           </a:p>
         </p:txBody>
       </p:sp>
@@ -22086,6 +22760,7 @@
           <a:lstStyle/>
           <a:p>
             <a:pPr algn="ctr"/>
+            <a:endParaRPr/>
           </a:p>
         </p:txBody>
       </p:sp>
@@ -22168,7 +22843,7 @@
 </file>
 
 <file path=ppt/slides/slide3.xml><?xml version="1.0" encoding="utf-8"?>
-<p:sld xmlns:a="http://schemas.openxmlformats.org/drawingml/2006/main" xmlns:p="http://schemas.openxmlformats.org/presentationml/2006/main" xmlns:r="http://schemas.openxmlformats.org/officeDocument/2006/relationships">
+<p:sld xmlns:a="http://schemas.openxmlformats.org/drawingml/2006/main" xmlns:r="http://schemas.openxmlformats.org/officeDocument/2006/relationships" xmlns:p="http://schemas.openxmlformats.org/presentationml/2006/main">
   <p:cSld>
     <p:bg>
       <p:bgPr>
@@ -22184,7 +22859,14 @@
         <p:cNvGrpSpPr/>
         <p:nvPr/>
       </p:nvGrpSpPr>
-      <p:grpSpPr/>
+      <p:grpSpPr>
+        <a:xfrm>
+          <a:off x="0" y="0"/>
+          <a:ext cx="0" cy="0"/>
+          <a:chOff x="0" y="0"/>
+          <a:chExt cx="0" cy="0"/>
+        </a:xfrm>
+      </p:grpSpPr>
       <p:sp>
         <p:nvSpPr>
           <p:cNvPr id="2" name="Rectangle 1"/>
@@ -22225,6 +22907,7 @@
           <a:lstStyle/>
           <a:p>
             <a:pPr algn="ctr"/>
+            <a:endParaRPr/>
           </a:p>
         </p:txBody>
       </p:sp>
@@ -22342,7 +23025,7 @@
 </file>
 
 <file path=ppt/slides/slide4.xml><?xml version="1.0" encoding="utf-8"?>
-<p:sld xmlns:a="http://schemas.openxmlformats.org/drawingml/2006/main" xmlns:p="http://schemas.openxmlformats.org/presentationml/2006/main" xmlns:r="http://schemas.openxmlformats.org/officeDocument/2006/relationships">
+<p:sld xmlns:a="http://schemas.openxmlformats.org/drawingml/2006/main" xmlns:r="http://schemas.openxmlformats.org/officeDocument/2006/relationships" xmlns:p="http://schemas.openxmlformats.org/presentationml/2006/main">
   <p:cSld>
     <p:bg>
       <p:bgPr>
@@ -22358,7 +23041,14 @@
         <p:cNvGrpSpPr/>
         <p:nvPr/>
       </p:nvGrpSpPr>
-      <p:grpSpPr/>
+      <p:grpSpPr>
+        <a:xfrm>
+          <a:off x="0" y="0"/>
+          <a:ext cx="0" cy="0"/>
+          <a:chOff x="0" y="0"/>
+          <a:chExt cx="0" cy="0"/>
+        </a:xfrm>
+      </p:grpSpPr>
       <p:sp>
         <p:nvSpPr>
           <p:cNvPr id="2" name="Rectangle 1"/>
@@ -22399,6 +23089,7 @@
           <a:lstStyle/>
           <a:p>
             <a:pPr algn="ctr"/>
+            <a:endParaRPr/>
           </a:p>
         </p:txBody>
       </p:sp>
@@ -22442,6 +23133,7 @@
           <a:lstStyle/>
           <a:p>
             <a:pPr algn="ctr"/>
+            <a:endParaRPr/>
           </a:p>
         </p:txBody>
       </p:sp>
@@ -22555,6 +23247,7 @@
           <a:lstStyle/>
           <a:p>
             <a:pPr algn="ctr"/>
+            <a:endParaRPr/>
           </a:p>
         </p:txBody>
       </p:sp>
@@ -22757,6 +23450,7 @@
           <a:lstStyle/>
           <a:p>
             <a:pPr algn="ctr"/>
+            <a:endParaRPr/>
           </a:p>
         </p:txBody>
       </p:sp>
@@ -22907,7 +23601,7 @@
 </file>
 
 <file path=ppt/slides/slide5.xml><?xml version="1.0" encoding="utf-8"?>
-<p:sld xmlns:a="http://schemas.openxmlformats.org/drawingml/2006/main" xmlns:p="http://schemas.openxmlformats.org/presentationml/2006/main" xmlns:r="http://schemas.openxmlformats.org/officeDocument/2006/relationships">
+<p:sld xmlns:a="http://schemas.openxmlformats.org/drawingml/2006/main" xmlns:r="http://schemas.openxmlformats.org/officeDocument/2006/relationships" xmlns:p="http://schemas.openxmlformats.org/presentationml/2006/main">
   <p:cSld>
     <p:bg>
       <p:bgPr>
@@ -22923,7 +23617,14 @@
         <p:cNvGrpSpPr/>
         <p:nvPr/>
       </p:nvGrpSpPr>
-      <p:grpSpPr/>
+      <p:grpSpPr>
+        <a:xfrm>
+          <a:off x="0" y="0"/>
+          <a:ext cx="0" cy="0"/>
+          <a:chOff x="0" y="0"/>
+          <a:chExt cx="0" cy="0"/>
+        </a:xfrm>
+      </p:grpSpPr>
       <p:sp>
         <p:nvSpPr>
           <p:cNvPr id="2" name="Rectangle 1"/>
@@ -22964,6 +23665,7 @@
           <a:lstStyle/>
           <a:p>
             <a:pPr algn="ctr"/>
+            <a:endParaRPr/>
           </a:p>
         </p:txBody>
       </p:sp>
@@ -23007,6 +23709,7 @@
           <a:lstStyle/>
           <a:p>
             <a:pPr algn="ctr"/>
+            <a:endParaRPr/>
           </a:p>
         </p:txBody>
       </p:sp>
@@ -23120,6 +23823,7 @@
           <a:lstStyle/>
           <a:p>
             <a:pPr algn="ctr"/>
+            <a:endParaRPr/>
           </a:p>
         </p:txBody>
       </p:sp>
@@ -23427,7 +24131,7 @@
 </file>
 
 <file path=ppt/slides/slide6.xml><?xml version="1.0" encoding="utf-8"?>
-<p:sld xmlns:a="http://schemas.openxmlformats.org/drawingml/2006/main" xmlns:p="http://schemas.openxmlformats.org/presentationml/2006/main" xmlns:r="http://schemas.openxmlformats.org/officeDocument/2006/relationships">
+<p:sld xmlns:a="http://schemas.openxmlformats.org/drawingml/2006/main" xmlns:r="http://schemas.openxmlformats.org/officeDocument/2006/relationships" xmlns:p="http://schemas.openxmlformats.org/presentationml/2006/main">
   <p:cSld>
     <p:bg>
       <p:bgPr>
@@ -23443,7 +24147,14 @@
         <p:cNvGrpSpPr/>
         <p:nvPr/>
       </p:nvGrpSpPr>
-      <p:grpSpPr/>
+      <p:grpSpPr>
+        <a:xfrm>
+          <a:off x="0" y="0"/>
+          <a:ext cx="0" cy="0"/>
+          <a:chOff x="0" y="0"/>
+          <a:chExt cx="0" cy="0"/>
+        </a:xfrm>
+      </p:grpSpPr>
       <p:sp>
         <p:nvSpPr>
           <p:cNvPr id="2" name="Rectangle 1"/>
@@ -23484,6 +24195,7 @@
           <a:lstStyle/>
           <a:p>
             <a:pPr algn="ctr"/>
+            <a:endParaRPr/>
           </a:p>
         </p:txBody>
       </p:sp>
@@ -23601,7 +24313,7 @@
 </file>
 
 <file path=ppt/slides/slide7.xml><?xml version="1.0" encoding="utf-8"?>
-<p:sld xmlns:a="http://schemas.openxmlformats.org/drawingml/2006/main" xmlns:p="http://schemas.openxmlformats.org/presentationml/2006/main" xmlns:r="http://schemas.openxmlformats.org/officeDocument/2006/relationships">
+<p:sld xmlns:a="http://schemas.openxmlformats.org/drawingml/2006/main" xmlns:r="http://schemas.openxmlformats.org/officeDocument/2006/relationships" xmlns:p="http://schemas.openxmlformats.org/presentationml/2006/main">
   <p:cSld>
     <p:bg>
       <p:bgPr>
@@ -23617,7 +24329,14 @@
         <p:cNvGrpSpPr/>
         <p:nvPr/>
       </p:nvGrpSpPr>
-      <p:grpSpPr/>
+      <p:grpSpPr>
+        <a:xfrm>
+          <a:off x="0" y="0"/>
+          <a:ext cx="0" cy="0"/>
+          <a:chOff x="0" y="0"/>
+          <a:chExt cx="0" cy="0"/>
+        </a:xfrm>
+      </p:grpSpPr>
       <p:sp>
         <p:nvSpPr>
           <p:cNvPr id="2" name="Rectangle 1"/>
@@ -23658,6 +24377,7 @@
           <a:lstStyle/>
           <a:p>
             <a:pPr algn="ctr"/>
+            <a:endParaRPr/>
           </a:p>
         </p:txBody>
       </p:sp>
@@ -23701,6 +24421,7 @@
           <a:lstStyle/>
           <a:p>
             <a:pPr algn="ctr"/>
+            <a:endParaRPr/>
           </a:p>
         </p:txBody>
       </p:sp>
@@ -23814,6 +24535,7 @@
           <a:lstStyle/>
           <a:p>
             <a:pPr algn="ctr"/>
+            <a:endParaRPr/>
           </a:p>
         </p:txBody>
       </p:sp>
@@ -23876,13 +24598,283 @@
           <a:p>
             <a:pPr algn="l"/>
             <a:r>
-              <a:rPr sz="1200" b="0" i="0">
+              <a:rPr sz="1200" b="0" i="0" dirty="0">
                 <a:solidFill>
                   <a:srgbClr val="6E6E73"/>
                 </a:solidFill>
                 <a:latin typeface="Calibri"/>
               </a:rPr>
-              <a:t>Platform web terdistribusi untuk mengelola kunjungan pasien, input rekam medis dokter, dan administrasi data klinik kampus dengan standar keamanan DevSecOps.</a:t>
+              <a:t>Platform web </a:t>
+            </a:r>
+            <a:r>
+              <a:rPr sz="1200" b="0" i="0" dirty="0" err="1">
+                <a:solidFill>
+                  <a:srgbClr val="6E6E73"/>
+                </a:solidFill>
+                <a:latin typeface="Calibri"/>
+              </a:rPr>
+              <a:t>terdistribusi</a:t>
+            </a:r>
+            <a:r>
+              <a:rPr sz="1200" b="0" i="0" dirty="0">
+                <a:solidFill>
+                  <a:srgbClr val="6E6E73"/>
+                </a:solidFill>
+                <a:latin typeface="Calibri"/>
+              </a:rPr>
+              <a:t> </a:t>
+            </a:r>
+            <a:r>
+              <a:rPr sz="1200" b="0" i="0" dirty="0" err="1">
+                <a:solidFill>
+                  <a:srgbClr val="6E6E73"/>
+                </a:solidFill>
+                <a:latin typeface="Calibri"/>
+              </a:rPr>
+              <a:t>untuk</a:t>
+            </a:r>
+            <a:r>
+              <a:rPr sz="1200" b="0" i="0" dirty="0">
+                <a:solidFill>
+                  <a:srgbClr val="6E6E73"/>
+                </a:solidFill>
+                <a:latin typeface="Calibri"/>
+              </a:rPr>
+              <a:t> </a:t>
+            </a:r>
+            <a:r>
+              <a:rPr sz="1200" b="0" i="0" dirty="0" err="1">
+                <a:solidFill>
+                  <a:srgbClr val="6E6E73"/>
+                </a:solidFill>
+                <a:latin typeface="Calibri"/>
+              </a:rPr>
+              <a:t>mengelola</a:t>
+            </a:r>
+            <a:r>
+              <a:rPr sz="1200" b="0" i="0" dirty="0">
+                <a:solidFill>
+                  <a:srgbClr val="6E6E73"/>
+                </a:solidFill>
+                <a:latin typeface="Calibri"/>
+              </a:rPr>
+              <a:t> </a:t>
+            </a:r>
+            <a:r>
+              <a:rPr sz="1200" b="0" i="0" dirty="0" err="1">
+                <a:solidFill>
+                  <a:srgbClr val="6E6E73"/>
+                </a:solidFill>
+                <a:latin typeface="Calibri"/>
+              </a:rPr>
+              <a:t>kunjungan</a:t>
+            </a:r>
+            <a:r>
+              <a:rPr sz="1200" b="0" i="0" dirty="0">
+                <a:solidFill>
+                  <a:srgbClr val="6E6E73"/>
+                </a:solidFill>
+                <a:latin typeface="Calibri"/>
+              </a:rPr>
+              <a:t> </a:t>
+            </a:r>
+            <a:r>
+              <a:rPr sz="1200" b="0" i="0" dirty="0" err="1">
+                <a:solidFill>
+                  <a:srgbClr val="6E6E73"/>
+                </a:solidFill>
+                <a:latin typeface="Calibri"/>
+              </a:rPr>
+              <a:t>pasien</a:t>
+            </a:r>
+            <a:r>
+              <a:rPr sz="1200" b="0" i="0" dirty="0">
+                <a:solidFill>
+                  <a:srgbClr val="6E6E73"/>
+                </a:solidFill>
+                <a:latin typeface="Calibri"/>
+              </a:rPr>
+              <a:t>, input </a:t>
+            </a:r>
+            <a:r>
+              <a:rPr sz="1200" b="0" i="0" dirty="0" err="1">
+                <a:solidFill>
+                  <a:srgbClr val="6E6E73"/>
+                </a:solidFill>
+                <a:latin typeface="Calibri"/>
+              </a:rPr>
+              <a:t>rekam</a:t>
+            </a:r>
+            <a:r>
+              <a:rPr sz="1200" b="0" i="0" dirty="0">
+                <a:solidFill>
+                  <a:srgbClr val="6E6E73"/>
+                </a:solidFill>
+                <a:latin typeface="Calibri"/>
+              </a:rPr>
+              <a:t> </a:t>
+            </a:r>
+            <a:r>
+              <a:rPr sz="1200" b="0" i="0" dirty="0" err="1">
+                <a:solidFill>
+                  <a:srgbClr val="6E6E73"/>
+                </a:solidFill>
+                <a:latin typeface="Calibri"/>
+              </a:rPr>
+              <a:t>medis</a:t>
+            </a:r>
+            <a:r>
+              <a:rPr sz="1200" b="0" i="0" dirty="0">
+                <a:solidFill>
+                  <a:srgbClr val="6E6E73"/>
+                </a:solidFill>
+                <a:latin typeface="Calibri"/>
+              </a:rPr>
+              <a:t> </a:t>
+            </a:r>
+            <a:r>
+              <a:rPr sz="1200" b="0" i="0" dirty="0" err="1">
+                <a:solidFill>
+                  <a:srgbClr val="6E6E73"/>
+                </a:solidFill>
+                <a:latin typeface="Calibri"/>
+              </a:rPr>
+              <a:t>dokter</a:t>
+            </a:r>
+            <a:r>
+              <a:rPr sz="1200" b="0" i="0" dirty="0">
+                <a:solidFill>
+                  <a:srgbClr val="6E6E73"/>
+                </a:solidFill>
+                <a:latin typeface="Calibri"/>
+              </a:rPr>
+              <a:t>, dan </a:t>
+            </a:r>
+            <a:r>
+              <a:rPr sz="1200" b="0" i="0" dirty="0" err="1">
+                <a:solidFill>
+                  <a:srgbClr val="6E6E73"/>
+                </a:solidFill>
+                <a:latin typeface="Calibri"/>
+              </a:rPr>
+              <a:t>administrasi</a:t>
+            </a:r>
+            <a:r>
+              <a:rPr sz="1200" b="0" i="0" dirty="0">
+                <a:solidFill>
+                  <a:srgbClr val="6E6E73"/>
+                </a:solidFill>
+                <a:latin typeface="Calibri"/>
+              </a:rPr>
+              <a:t> data </a:t>
+            </a:r>
+            <a:r>
+              <a:rPr sz="1200" b="0" i="0" dirty="0" err="1">
+                <a:solidFill>
+                  <a:srgbClr val="6E6E73"/>
+                </a:solidFill>
+                <a:latin typeface="Calibri"/>
+              </a:rPr>
+              <a:t>klinik</a:t>
+            </a:r>
+            <a:r>
+              <a:rPr sz="1200" b="0" i="0" dirty="0">
+                <a:solidFill>
+                  <a:srgbClr val="6E6E73"/>
+                </a:solidFill>
+                <a:latin typeface="Calibri"/>
+              </a:rPr>
+              <a:t> </a:t>
+            </a:r>
+            <a:r>
+              <a:rPr sz="1200" b="0" i="0" dirty="0" err="1">
+                <a:solidFill>
+                  <a:srgbClr val="6E6E73"/>
+                </a:solidFill>
+                <a:latin typeface="Calibri"/>
+              </a:rPr>
+              <a:t>kampus</a:t>
+            </a:r>
+            <a:r>
+              <a:rPr sz="1200" b="0" i="0" dirty="0">
+                <a:solidFill>
+                  <a:srgbClr val="6E6E73"/>
+                </a:solidFill>
+                <a:latin typeface="Calibri"/>
+              </a:rPr>
+              <a:t> </a:t>
+            </a:r>
+            <a:r>
+              <a:rPr sz="1200" b="0" i="0" dirty="0" err="1">
+                <a:solidFill>
+                  <a:srgbClr val="6E6E73"/>
+                </a:solidFill>
+                <a:latin typeface="Calibri"/>
+              </a:rPr>
+              <a:t>dengan</a:t>
+            </a:r>
+            <a:r>
+              <a:rPr sz="1200" b="0" i="0" dirty="0">
+                <a:solidFill>
+                  <a:srgbClr val="6E6E73"/>
+                </a:solidFill>
+                <a:latin typeface="Calibri"/>
+              </a:rPr>
+              <a:t> </a:t>
+            </a:r>
+            <a:r>
+              <a:rPr sz="1200" b="0" i="0" dirty="0" err="1">
+                <a:solidFill>
+                  <a:srgbClr val="6E6E73"/>
+                </a:solidFill>
+                <a:latin typeface="Calibri"/>
+              </a:rPr>
+              <a:t>standar</a:t>
+            </a:r>
+            <a:r>
+              <a:rPr sz="1200" b="0" i="0" dirty="0">
+                <a:solidFill>
+                  <a:srgbClr val="6E6E73"/>
+                </a:solidFill>
+                <a:latin typeface="Calibri"/>
+              </a:rPr>
+              <a:t> </a:t>
+            </a:r>
+            <a:r>
+              <a:rPr sz="1200" b="0" i="0" dirty="0" err="1">
+                <a:solidFill>
+                  <a:srgbClr val="6E6E73"/>
+                </a:solidFill>
+                <a:latin typeface="Calibri"/>
+              </a:rPr>
+              <a:t>keamanan</a:t>
+            </a:r>
+            <a:r>
+              <a:rPr sz="1200" b="0" i="0" dirty="0">
+                <a:solidFill>
+                  <a:srgbClr val="6E6E73"/>
+                </a:solidFill>
+                <a:latin typeface="Calibri"/>
+              </a:rPr>
+              <a:t> </a:t>
+            </a:r>
+            <a:r>
+              <a:rPr sz="1200" b="0" i="0" dirty="0" err="1">
+                <a:solidFill>
+                  <a:srgbClr val="6E6E73"/>
+                </a:solidFill>
+                <a:latin typeface="Calibri"/>
+              </a:rPr>
+              <a:t>DevSecOps</a:t>
+            </a:r>
+            <a:r>
+              <a:rPr sz="1200" b="0" i="0" dirty="0">
+                <a:solidFill>
+                  <a:srgbClr val="6E6E73"/>
+                </a:solidFill>
+                <a:latin typeface="Calibri"/>
+              </a:rPr>
+              <a:t>.</a:t>
             </a:r>
           </a:p>
         </p:txBody>
@@ -23895,8 +24887,8 @@
         </p:nvSpPr>
         <p:spPr>
           <a:xfrm>
-            <a:off x="548640" y="2286000"/>
-            <a:ext cx="3566160" cy="1371600"/>
+            <a:off x="548640" y="2241764"/>
+            <a:ext cx="3566160" cy="548640"/>
           </a:xfrm>
           <a:prstGeom prst="rect">
             <a:avLst/>
@@ -23927,6 +24919,7 @@
           <a:lstStyle/>
           <a:p>
             <a:pPr algn="ctr"/>
+            <a:endParaRPr/>
           </a:p>
         </p:txBody>
       </p:sp>
@@ -23938,8 +24931,8 @@
         </p:nvSpPr>
         <p:spPr>
           <a:xfrm>
-            <a:off x="548640" y="2286000"/>
-            <a:ext cx="3566160" cy="1371600"/>
+            <a:off x="517380" y="2371970"/>
+            <a:ext cx="3566160" cy="292388"/>
           </a:xfrm>
           <a:prstGeom prst="rect">
             <a:avLst/>
@@ -23954,7 +24947,7 @@
           <a:p>
             <a:pPr algn="ctr"/>
             <a:r>
-              <a:rPr sz="1300" b="1" i="0">
+              <a:rPr sz="1300" b="1" i="0" dirty="0">
                 <a:solidFill>
                   <a:srgbClr val="FFFFFF"/>
                 </a:solidFill>
@@ -23973,7 +24966,7 @@
         </p:nvSpPr>
         <p:spPr>
           <a:xfrm>
-            <a:off x="548640" y="3657600"/>
+            <a:off x="548640" y="2795876"/>
             <a:ext cx="3566160" cy="1188720"/>
           </a:xfrm>
           <a:prstGeom prst="rect">
@@ -24007,6 +25000,7 @@
           <a:lstStyle/>
           <a:p>
             <a:pPr algn="ctr"/>
+            <a:endParaRPr/>
           </a:p>
         </p:txBody>
       </p:sp>
@@ -24018,7 +25012,7 @@
         </p:nvSpPr>
         <p:spPr>
           <a:xfrm>
-            <a:off x="640080" y="3749039"/>
+            <a:off x="640080" y="2887315"/>
             <a:ext cx="3383280" cy="1005840"/>
           </a:xfrm>
           <a:prstGeom prst="rect">
@@ -24053,8 +25047,8 @@
         </p:nvSpPr>
         <p:spPr>
           <a:xfrm>
-            <a:off x="4297679" y="2286000"/>
-            <a:ext cx="3566160" cy="1371600"/>
+            <a:off x="4297679" y="2239110"/>
+            <a:ext cx="3566160" cy="548640"/>
           </a:xfrm>
           <a:prstGeom prst="rect">
             <a:avLst/>
@@ -24085,6 +25079,7 @@
           <a:lstStyle/>
           <a:p>
             <a:pPr algn="ctr"/>
+            <a:endParaRPr/>
           </a:p>
         </p:txBody>
       </p:sp>
@@ -24096,7 +25091,7 @@
         </p:nvSpPr>
         <p:spPr>
           <a:xfrm>
-            <a:off x="4297679" y="2286000"/>
+            <a:off x="4251960" y="2379785"/>
             <a:ext cx="3566160" cy="1371600"/>
           </a:xfrm>
           <a:prstGeom prst="rect">
@@ -24112,7 +25107,7 @@
           <a:p>
             <a:pPr algn="ctr"/>
             <a:r>
-              <a:rPr sz="1300" b="1" i="0">
+              <a:rPr sz="1300" b="1" i="0" dirty="0">
                 <a:solidFill>
                   <a:srgbClr val="FFFFFF"/>
                 </a:solidFill>
@@ -24131,7 +25126,7 @@
         </p:nvSpPr>
         <p:spPr>
           <a:xfrm>
-            <a:off x="4297679" y="3657600"/>
+            <a:off x="4297679" y="2797916"/>
             <a:ext cx="3566160" cy="1188720"/>
           </a:xfrm>
           <a:prstGeom prst="rect">
@@ -24165,6 +25160,7 @@
           <a:lstStyle/>
           <a:p>
             <a:pPr algn="ctr"/>
+            <a:endParaRPr/>
           </a:p>
         </p:txBody>
       </p:sp>
@@ -24176,7 +25172,7 @@
         </p:nvSpPr>
         <p:spPr>
           <a:xfrm>
-            <a:off x="4389119" y="3749039"/>
+            <a:off x="4389119" y="2889355"/>
             <a:ext cx="3383280" cy="1005840"/>
           </a:xfrm>
           <a:prstGeom prst="rect">
@@ -24192,14 +25188,83 @@
           <a:p>
             <a:pPr algn="l"/>
             <a:r>
-              <a:rPr sz="1100" b="0" i="0">
+              <a:rPr sz="1100" b="0" i="0" dirty="0">
                 <a:solidFill>
                   <a:srgbClr val="1D1D1F"/>
                 </a:solidFill>
                 <a:latin typeface="Calibri"/>
               </a:rPr>
-              <a:t>Input rekam medis, antrian, resep</a:t>
-            </a:r>
+              <a:t>Input </a:t>
+            </a:r>
+            <a:r>
+              <a:rPr sz="1100" b="0" i="0" dirty="0" err="1">
+                <a:solidFill>
+                  <a:srgbClr val="1D1D1F"/>
+                </a:solidFill>
+                <a:latin typeface="Calibri"/>
+              </a:rPr>
+              <a:t>rekam</a:t>
+            </a:r>
+            <a:r>
+              <a:rPr sz="1100" b="0" i="0" dirty="0">
+                <a:solidFill>
+                  <a:srgbClr val="1D1D1F"/>
+                </a:solidFill>
+                <a:latin typeface="Calibri"/>
+              </a:rPr>
+              <a:t> </a:t>
+            </a:r>
+            <a:r>
+              <a:rPr sz="1100" b="0" i="0" dirty="0" err="1">
+                <a:solidFill>
+                  <a:srgbClr val="1D1D1F"/>
+                </a:solidFill>
+                <a:latin typeface="Calibri"/>
+              </a:rPr>
+              <a:t>medis</a:t>
+            </a:r>
+            <a:r>
+              <a:rPr sz="1100" b="0" i="0" dirty="0">
+                <a:solidFill>
+                  <a:srgbClr val="1D1D1F"/>
+                </a:solidFill>
+                <a:latin typeface="Calibri"/>
+              </a:rPr>
+              <a:t>, </a:t>
+            </a:r>
+            <a:r>
+              <a:rPr sz="1100" b="0" i="0" dirty="0" err="1">
+                <a:solidFill>
+                  <a:srgbClr val="1D1D1F"/>
+                </a:solidFill>
+                <a:latin typeface="Calibri"/>
+              </a:rPr>
+              <a:t>antrian</a:t>
+            </a:r>
+            <a:r>
+              <a:rPr sz="1100" b="0" i="0" dirty="0">
+                <a:solidFill>
+                  <a:srgbClr val="1D1D1F"/>
+                </a:solidFill>
+                <a:latin typeface="Calibri"/>
+              </a:rPr>
+              <a:t>, </a:t>
+            </a:r>
+            <a:r>
+              <a:rPr sz="1100" b="0" i="0" dirty="0" err="1">
+                <a:solidFill>
+                  <a:srgbClr val="1D1D1F"/>
+                </a:solidFill>
+                <a:latin typeface="Calibri"/>
+              </a:rPr>
+              <a:t>resep</a:t>
+            </a:r>
+            <a:endParaRPr sz="1100" b="0" i="0" dirty="0">
+              <a:solidFill>
+                <a:srgbClr val="1D1D1F"/>
+              </a:solidFill>
+              <a:latin typeface="Calibri"/>
+            </a:endParaRPr>
           </a:p>
         </p:txBody>
       </p:sp>
@@ -24211,8 +25276,8 @@
         </p:nvSpPr>
         <p:spPr>
           <a:xfrm>
-            <a:off x="8046718" y="2286000"/>
-            <a:ext cx="3566160" cy="1371600"/>
+            <a:off x="8046718" y="2239110"/>
+            <a:ext cx="3566160" cy="558806"/>
           </a:xfrm>
           <a:prstGeom prst="rect">
             <a:avLst/>
@@ -24243,6 +25308,7 @@
           <a:lstStyle/>
           <a:p>
             <a:pPr algn="ctr"/>
+            <a:endParaRPr/>
           </a:p>
         </p:txBody>
       </p:sp>
@@ -24254,7 +25320,7 @@
         </p:nvSpPr>
         <p:spPr>
           <a:xfrm>
-            <a:off x="8046718" y="2286000"/>
+            <a:off x="7956796" y="2353215"/>
             <a:ext cx="3566160" cy="1371600"/>
           </a:xfrm>
           <a:prstGeom prst="rect">
@@ -24270,14 +25336,29 @@
           <a:p>
             <a:pPr algn="ctr"/>
             <a:r>
-              <a:rPr sz="1300" b="1" i="0">
+              <a:rPr sz="1300" b="1" i="0" dirty="0">
                 <a:solidFill>
                   <a:srgbClr val="FFFFFF"/>
                 </a:solidFill>
                 <a:latin typeface="Calibri"/>
               </a:rPr>
-              <a:t>🔵  Pasien</a:t>
-            </a:r>
+              <a:t>🔵  </a:t>
+            </a:r>
+            <a:r>
+              <a:rPr sz="1300" b="1" i="0" dirty="0" err="1">
+                <a:solidFill>
+                  <a:srgbClr val="FFFFFF"/>
+                </a:solidFill>
+                <a:latin typeface="Calibri"/>
+              </a:rPr>
+              <a:t>Pasien</a:t>
+            </a:r>
+            <a:endParaRPr sz="1300" b="1" i="0" dirty="0">
+              <a:solidFill>
+                <a:srgbClr val="FFFFFF"/>
+              </a:solidFill>
+              <a:latin typeface="Calibri"/>
+            </a:endParaRPr>
           </a:p>
         </p:txBody>
       </p:sp>
@@ -24289,7 +25370,7 @@
         </p:nvSpPr>
         <p:spPr>
           <a:xfrm>
-            <a:off x="8046718" y="3657600"/>
+            <a:off x="8046718" y="2805721"/>
             <a:ext cx="3566160" cy="1188720"/>
           </a:xfrm>
           <a:prstGeom prst="rect">
@@ -24323,6 +25404,7 @@
           <a:lstStyle/>
           <a:p>
             <a:pPr algn="ctr"/>
+            <a:endParaRPr/>
           </a:p>
         </p:txBody>
       </p:sp>
@@ -24334,7 +25416,7 @@
         </p:nvSpPr>
         <p:spPr>
           <a:xfrm>
-            <a:off x="8138158" y="3749039"/>
+            <a:off x="8138158" y="2897160"/>
             <a:ext cx="3383280" cy="1005840"/>
           </a:xfrm>
           <a:prstGeom prst="rect">
@@ -24370,7 +25452,7 @@
 </file>
 
 <file path=ppt/slides/slide8.xml><?xml version="1.0" encoding="utf-8"?>
-<p:sld xmlns:a="http://schemas.openxmlformats.org/drawingml/2006/main" xmlns:p="http://schemas.openxmlformats.org/presentationml/2006/main" xmlns:r="http://schemas.openxmlformats.org/officeDocument/2006/relationships">
+<p:sld xmlns:a="http://schemas.openxmlformats.org/drawingml/2006/main" xmlns:r="http://schemas.openxmlformats.org/officeDocument/2006/relationships" xmlns:p="http://schemas.openxmlformats.org/presentationml/2006/main">
   <p:cSld>
     <p:bg>
       <p:bgPr>
@@ -24386,7 +25468,14 @@
         <p:cNvGrpSpPr/>
         <p:nvPr/>
       </p:nvGrpSpPr>
-      <p:grpSpPr/>
+      <p:grpSpPr>
+        <a:xfrm>
+          <a:off x="0" y="0"/>
+          <a:ext cx="0" cy="0"/>
+          <a:chOff x="0" y="0"/>
+          <a:chExt cx="0" cy="0"/>
+        </a:xfrm>
+      </p:grpSpPr>
       <p:sp>
         <p:nvSpPr>
           <p:cNvPr id="2" name="Rectangle 1"/>
@@ -24427,6 +25516,7 @@
           <a:lstStyle/>
           <a:p>
             <a:pPr algn="ctr"/>
+            <a:endParaRPr/>
           </a:p>
         </p:txBody>
       </p:sp>
@@ -24470,6 +25560,7 @@
           <a:lstStyle/>
           <a:p>
             <a:pPr algn="ctr"/>
+            <a:endParaRPr/>
           </a:p>
         </p:txBody>
       </p:sp>
@@ -24583,6 +25674,7 @@
           <a:lstStyle/>
           <a:p>
             <a:pPr algn="ctr"/>
+            <a:endParaRPr/>
           </a:p>
         </p:txBody>
       </p:sp>
@@ -24687,6 +25779,7 @@
           <a:lstStyle/>
           <a:p>
             <a:pPr algn="ctr"/>
+            <a:endParaRPr/>
           </a:p>
         </p:txBody>
       </p:sp>
@@ -24730,6 +25823,7 @@
           <a:lstStyle/>
           <a:p>
             <a:pPr algn="ctr"/>
+            <a:endParaRPr/>
           </a:p>
         </p:txBody>
       </p:sp>
@@ -24843,6 +25937,7 @@
           <a:lstStyle/>
           <a:p>
             <a:pPr algn="ctr"/>
+            <a:endParaRPr/>
           </a:p>
         </p:txBody>
       </p:sp>
@@ -24886,6 +25981,7 @@
           <a:lstStyle/>
           <a:p>
             <a:pPr algn="ctr"/>
+            <a:endParaRPr/>
           </a:p>
         </p:txBody>
       </p:sp>
@@ -24999,6 +26095,7 @@
           <a:lstStyle/>
           <a:p>
             <a:pPr algn="ctr"/>
+            <a:endParaRPr/>
           </a:p>
         </p:txBody>
       </p:sp>
@@ -25042,6 +26139,7 @@
           <a:lstStyle/>
           <a:p>
             <a:pPr algn="ctr"/>
+            <a:endParaRPr/>
           </a:p>
         </p:txBody>
       </p:sp>
@@ -25155,6 +26253,7 @@
           <a:lstStyle/>
           <a:p>
             <a:pPr algn="ctr"/>
+            <a:endParaRPr/>
           </a:p>
         </p:txBody>
       </p:sp>
@@ -25198,6 +26297,7 @@
           <a:lstStyle/>
           <a:p>
             <a:pPr algn="ctr"/>
+            <a:endParaRPr/>
           </a:p>
         </p:txBody>
       </p:sp>
@@ -25280,7 +26380,7 @@
 </file>
 
 <file path=ppt/slides/slide9.xml><?xml version="1.0" encoding="utf-8"?>
-<p:sld xmlns:a="http://schemas.openxmlformats.org/drawingml/2006/main" xmlns:p="http://schemas.openxmlformats.org/presentationml/2006/main" xmlns:r="http://schemas.openxmlformats.org/officeDocument/2006/relationships">
+<p:sld xmlns:a="http://schemas.openxmlformats.org/drawingml/2006/main" xmlns:r="http://schemas.openxmlformats.org/officeDocument/2006/relationships" xmlns:p="http://schemas.openxmlformats.org/presentationml/2006/main">
   <p:cSld>
     <p:bg>
       <p:bgPr>
@@ -25296,7 +26396,14 @@
         <p:cNvGrpSpPr/>
         <p:nvPr/>
       </p:nvGrpSpPr>
-      <p:grpSpPr/>
+      <p:grpSpPr>
+        <a:xfrm>
+          <a:off x="0" y="0"/>
+          <a:ext cx="0" cy="0"/>
+          <a:chOff x="0" y="0"/>
+          <a:chExt cx="0" cy="0"/>
+        </a:xfrm>
+      </p:grpSpPr>
       <p:sp>
         <p:nvSpPr>
           <p:cNvPr id="2" name="Rectangle 1"/>
@@ -25337,6 +26444,7 @@
           <a:lstStyle/>
           <a:p>
             <a:pPr algn="ctr"/>
+            <a:endParaRPr/>
           </a:p>
         </p:txBody>
       </p:sp>
@@ -25380,6 +26488,7 @@
           <a:lstStyle/>
           <a:p>
             <a:pPr algn="ctr"/>
+            <a:endParaRPr/>
           </a:p>
         </p:txBody>
       </p:sp>
@@ -25493,6 +26602,7 @@
           <a:lstStyle/>
           <a:p>
             <a:pPr algn="ctr"/>
+            <a:endParaRPr/>
           </a:p>
         </p:txBody>
       </p:sp>

</xml_diff>